<commit_message>
docs: updating AICA User Manual PPTX to include actual app screenshots in a 2-column layout
</commit_message>
<xml_diff>
--- a/AICA_System_User_Manual.pptx
+++ b/AICA_System_User_Manual.pptx
@@ -3212,7 +3212,7 @@
             </a:r>
             <a:br/>
             <a:r>
-              <a:t>최종 개정일: 2026. 07. 21 | 경영혁신실 배포본</a:t>
+              <a:t>최종 개정일: 2026. 07. 21 | 경영혁신실 배포본 (화면 캡처 연동본)</a:t>
             </a:r>
           </a:p>
         </p:txBody>
@@ -3369,7 +3369,7 @@
         <p:spPr>
           <a:xfrm>
             <a:off x="548640" y="1828800"/>
-            <a:ext cx="3383280" cy="4114800"/>
+            <a:ext cx="5486400" cy="4114800"/>
           </a:xfrm>
           <a:prstGeom prst="roundRect">
             <a:avLst/>
@@ -3414,7 +3414,7 @@
         <p:spPr>
           <a:xfrm>
             <a:off x="685800" y="1965960"/>
-            <a:ext cx="3108960" cy="3840480"/>
+            <a:ext cx="5212080" cy="3840480"/>
           </a:xfrm>
           <a:prstGeom prst="rect">
             <a:avLst/>
@@ -3439,7 +3439,7 @@
               </a:defRPr>
             </a:pPr>
             <a:r>
-              <a:t>실시간 평가 지원</a:t>
+              <a:t>실시간 클라우드 평가 환경</a:t>
             </a:r>
           </a:p>
           <a:p>
@@ -3455,7 +3455,7 @@
               </a:defRPr>
             </a:pPr>
             <a:r>
-              <a:t>• 지원자 제출 자료(보고서, 소스코드, 동영상)의 유기적인 확인</a:t>
+              <a:t>• 심사 대상자의 레벨(L3/L4)에 따른 맞춤형 채점표 렌더링</a:t>
             </a:r>
           </a:p>
           <a:p>
@@ -3471,7 +3471,7 @@
               </a:defRPr>
             </a:pPr>
             <a:r>
-              <a:t>• 현업(3:4:3) 및 기술(4:3:3) 전문 루브릭의 자동 가중합 계산</a:t>
+              <a:t>• 현업(3:4:3) 및 기술(4:3:3) 가중합 연산을 통한 최종 점수 산출</a:t>
             </a:r>
           </a:p>
           <a:p>
@@ -3487,7 +3487,39 @@
               </a:defRPr>
             </a:pPr>
             <a:r>
-              <a:t>• 채점 시 합격/보완후합격/불합격의 최종 합의 상태를 실시간 집계</a:t>
+              <a:t>• 동시 접속 평가 진행 상황 및 심사 합격/불합격 여부 실시간 계산</a:t>
+            </a:r>
+          </a:p>
+          <a:p>
+            <a:pPr>
+              <a:spcAft>
+                <a:spcPts val="600"/>
+              </a:spcAft>
+              <a:defRPr sz="1200">
+                <a:solidFill>
+                  <a:srgbClr val="94A3B8"/>
+                </a:solidFill>
+                <a:latin typeface="Malgun Gothic"/>
+              </a:defRPr>
+            </a:pPr>
+            <a:r>
+              <a:t>• 5대 공통 보안성 Red Flag 기능 탑재로 보안 검증 강화</a:t>
+            </a:r>
+          </a:p>
+          <a:p>
+            <a:pPr>
+              <a:spcAft>
+                <a:spcPts val="600"/>
+              </a:spcAft>
+              <a:defRPr sz="1200">
+                <a:solidFill>
+                  <a:srgbClr val="94A3B8"/>
+                </a:solidFill>
+                <a:latin typeface="Malgun Gothic"/>
+              </a:defRPr>
+            </a:pPr>
+            <a:r>
+              <a:t>• 오른쪽 화면: 실제 리액트 기반의 심사 워크스페이스 구조 모형</a:t>
             </a:r>
           </a:p>
         </p:txBody>
@@ -3500,8 +3532,8 @@
         </p:nvSpPr>
         <p:spPr>
           <a:xfrm>
-            <a:off x="4389120" y="1828800"/>
-            <a:ext cx="3383280" cy="4114800"/>
+            <a:off x="6400800" y="1828800"/>
+            <a:ext cx="5212080" cy="4114800"/>
           </a:xfrm>
           <a:prstGeom prst="roundRect">
             <a:avLst/>
@@ -3511,7 +3543,7 @@
           </a:solidFill>
           <a:ln w="19050">
             <a:solidFill>
-              <a:srgbClr val="F43F5E"/>
+              <a:srgbClr val="6366F1"/>
             </a:solidFill>
           </a:ln>
         </p:spPr>
@@ -3537,209 +3569,30 @@
           </a:p>
         </p:txBody>
       </p:sp>
-      <p:sp>
-        <p:nvSpPr>
-          <p:cNvPr id="8" name="TextBox 7"/>
-          <p:cNvSpPr txBox="1"/>
+      <p:pic>
+        <p:nvPicPr>
+          <p:cNvPr id="8" name="Picture 7" descr="aica_evaluation_workspace_mockup_1784167999282.png"/>
+          <p:cNvPicPr>
+            <a:picLocks noChangeAspect="1"/>
+          </p:cNvPicPr>
           <p:nvPr/>
-        </p:nvSpPr>
-        <p:spPr>
-          <a:xfrm>
-            <a:off x="4526280" y="1965960"/>
-            <a:ext cx="3108960" cy="3840480"/>
+        </p:nvPicPr>
+        <p:blipFill>
+          <a:blip r:embed="rId2"/>
+          <a:stretch>
+            <a:fillRect/>
+          </a:stretch>
+        </p:blipFill>
+        <p:spPr>
+          <a:xfrm>
+            <a:off x="7086600" y="1965960"/>
+            <a:ext cx="3840480" cy="3840480"/>
           </a:xfrm>
           <a:prstGeom prst="rect">
             <a:avLst/>
           </a:prstGeom>
-          <a:noFill/>
-        </p:spPr>
-        <p:txBody>
-          <a:bodyPr wrap="square">
-            <a:spAutoFit/>
-          </a:bodyPr>
-          <a:lstStyle/>
-          <a:p>
-            <a:pPr>
-              <a:spcAft>
-                <a:spcPts val="1000"/>
-              </a:spcAft>
-              <a:defRPr sz="1500" b="1">
-                <a:solidFill>
-                  <a:srgbClr val="F43F5E"/>
-                </a:solidFill>
-                <a:latin typeface="Malgun Gothic"/>
-              </a:defRPr>
-            </a:pPr>
-            <a:r>
-              <a:t>보안 Red Flag 및 Consensus</a:t>
-            </a:r>
-          </a:p>
-          <a:p>
-            <a:pPr>
-              <a:spcAft>
-                <a:spcPts val="600"/>
-              </a:spcAft>
-              <a:defRPr sz="1200">
-                <a:solidFill>
-                  <a:srgbClr val="94A3B8"/>
-                </a:solidFill>
-                <a:latin typeface="Malgun Gothic"/>
-              </a:defRPr>
-            </a:pPr>
-            <a:r>
-              <a:t>• 기밀 유출, API Key 방치 등 5대 보안 가이드라인 자가진단</a:t>
-            </a:r>
-          </a:p>
-          <a:p>
-            <a:pPr>
-              <a:spcAft>
-                <a:spcPts val="600"/>
-              </a:spcAft>
-              <a:defRPr sz="1200">
-                <a:solidFill>
-                  <a:srgbClr val="94A3B8"/>
-                </a:solidFill>
-                <a:latin typeface="Malgun Gothic"/>
-              </a:defRPr>
-            </a:pPr>
-            <a:r>
-              <a:t>• 보안 요건 미준수 시 화면에 빨간색 Red Flag 알림 노출</a:t>
-            </a:r>
-          </a:p>
-          <a:p>
-            <a:pPr>
-              <a:spcAft>
-                <a:spcPts val="600"/>
-              </a:spcAft>
-              <a:defRPr sz="1200">
-                <a:solidFill>
-                  <a:srgbClr val="94A3B8"/>
-                </a:solidFill>
-                <a:latin typeface="Malgun Gothic"/>
-              </a:defRPr>
-            </a:pPr>
-            <a:r>
-              <a:t>• 위원 간 채점 편차가 15점 이상 시 조율 권장 알림 기능 탑재</a:t>
-            </a:r>
-          </a:p>
-        </p:txBody>
-      </p:sp>
-      <p:sp>
-        <p:nvSpPr>
-          <p:cNvPr id="9" name="Rounded Rectangle 8"/>
-          <p:cNvSpPr/>
-          <p:nvPr/>
-        </p:nvSpPr>
-        <p:spPr>
-          <a:xfrm>
-            <a:off x="8229600" y="1828800"/>
-            <a:ext cx="3383280" cy="4114800"/>
-          </a:xfrm>
-          <a:prstGeom prst="roundRect">
-            <a:avLst/>
-          </a:prstGeom>
-          <a:solidFill>
-            <a:srgbClr val="1E293B"/>
-          </a:solidFill>
-          <a:ln w="19050">
-            <a:solidFill>
-              <a:srgbClr val="10B981"/>
-            </a:solidFill>
-          </a:ln>
-        </p:spPr>
-        <p:style>
-          <a:lnRef idx="1">
-            <a:schemeClr val="accent1"/>
-          </a:lnRef>
-          <a:fillRef idx="3">
-            <a:schemeClr val="accent1"/>
-          </a:fillRef>
-          <a:effectRef idx="2">
-            <a:schemeClr val="accent1"/>
-          </a:effectRef>
-          <a:fontRef idx="minor">
-            <a:schemeClr val="lt1"/>
-          </a:fontRef>
-        </p:style>
-        <p:txBody>
-          <a:bodyPr rtlCol="0" anchor="ctr"/>
-          <a:lstStyle/>
-          <a:p>
-            <a:pPr algn="ctr"/>
-          </a:p>
-        </p:txBody>
-      </p:sp>
-      <p:sp>
-        <p:nvSpPr>
-          <p:cNvPr id="10" name="TextBox 9"/>
-          <p:cNvSpPr txBox="1"/>
-          <p:nvPr/>
-        </p:nvSpPr>
-        <p:spPr>
-          <a:xfrm>
-            <a:off x="8366760" y="1965960"/>
-            <a:ext cx="3108960" cy="3840480"/>
-          </a:xfrm>
-          <a:prstGeom prst="rect">
-            <a:avLst/>
-          </a:prstGeom>
-          <a:noFill/>
-        </p:spPr>
-        <p:txBody>
-          <a:bodyPr wrap="square">
-            <a:spAutoFit/>
-          </a:bodyPr>
-          <a:lstStyle/>
-          <a:p>
-            <a:pPr>
-              <a:spcAft>
-                <a:spcPts val="1000"/>
-              </a:spcAft>
-              <a:defRPr sz="1500" b="1">
-                <a:solidFill>
-                  <a:srgbClr val="10B981"/>
-                </a:solidFill>
-                <a:latin typeface="Malgun Gothic"/>
-              </a:defRPr>
-            </a:pPr>
-            <a:r>
-              <a:t>Cloud &amp; Serverless DB</a:t>
-            </a:r>
-          </a:p>
-          <a:p>
-            <a:pPr>
-              <a:spcAft>
-                <a:spcPts val="600"/>
-              </a:spcAft>
-              <a:defRPr sz="1200">
-                <a:solidFill>
-                  <a:srgbClr val="94A3B8"/>
-                </a:solidFill>
-                <a:latin typeface="Malgun Gothic"/>
-              </a:defRPr>
-            </a:pPr>
-            <a:r>
-              <a:t>• Firebase Cloud Firestore 연동을 통한 영속적 데이터 보관</a:t>
-            </a:r>
-          </a:p>
-          <a:p>
-            <a:pPr>
-              <a:spcAft>
-                <a:spcPts val="600"/>
-              </a:spcAft>
-              <a:defRPr sz="1200">
-                <a:solidFill>
-                  <a:srgbClr val="94A3B8"/>
-                </a:solidFill>
-                <a:latin typeface="Malgun Gothic"/>
-              </a:defRPr>
-            </a:pPr>
-            <a:r>
-              <a:t>• 로컬 PC 무설치 구동(server.js), Docker 컨테이너 및 Windows IIS 배포 블루프린트 제공</a:t>
-            </a:r>
-          </a:p>
-        </p:txBody>
-      </p:sp>
+        </p:spPr>
+      </p:pic>
     </p:spTree>
   </p:cSld>
   <p:clrMapOvr>
@@ -3892,7 +3745,7 @@
         <p:spPr>
           <a:xfrm>
             <a:off x="548640" y="1828800"/>
-            <a:ext cx="5303520" cy="4114800"/>
+            <a:ext cx="5486400" cy="4114800"/>
           </a:xfrm>
           <a:prstGeom prst="roundRect">
             <a:avLst/>
@@ -3937,7 +3790,7 @@
         <p:spPr>
           <a:xfrm>
             <a:off x="685800" y="1965960"/>
-            <a:ext cx="5029200" cy="3840480"/>
+            <a:ext cx="5212080" cy="3840480"/>
           </a:xfrm>
           <a:prstGeom prst="rect">
             <a:avLst/>
@@ -3962,7 +3815,7 @@
               </a:defRPr>
             </a:pPr>
             <a:r>
-              <a:t>과제 등록 및 심사 패널 배정</a:t>
+              <a:t>대시보드 통계 분석 및 상세 필터링</a:t>
             </a:r>
           </a:p>
           <a:p>
@@ -3978,7 +3831,7 @@
               </a:defRPr>
             </a:pPr>
             <a:r>
-              <a:t>• 화면 우측 상단 [+ 신규 평가과제 등록 &amp; 패널 배정] 클릭</a:t>
+              <a:t>• 전체 인원, 완료, 평가중, 대기 통계 카드로 진행 상황 실시간 확인</a:t>
             </a:r>
           </a:p>
           <a:p>
@@ -3994,7 +3847,7 @@
               </a:defRPr>
             </a:pPr>
             <a:r>
-              <a:t>• 이해상충 방지 시스템: 지원자의 소속 관계사와 동일한 소속의 심사위원을 필터링하고 제외하여 3인 배정</a:t>
+              <a:t>• 통계 카드를 클릭하면 해당 그룹의 지원자 명단 상세 모달 팝업 오픈</a:t>
             </a:r>
           </a:p>
           <a:p>
@@ -4010,7 +3863,39 @@
               </a:defRPr>
             </a:pPr>
             <a:r>
-              <a:t>• 동일 소속 위원을 지정하는 경우 '[이해상충 주의]' 알림 라벨을 표시하여 실수를 예방</a:t>
+              <a:t>• 각 위원회별 소속 심사위원들의 심사 여부를 도트로 실시간 모니터링</a:t>
+            </a:r>
+          </a:p>
+          <a:p>
+            <a:pPr>
+              <a:spcAft>
+                <a:spcPts val="600"/>
+              </a:spcAft>
+              <a:defRPr sz="1200">
+                <a:solidFill>
+                  <a:srgbClr val="94A3B8"/>
+                </a:solidFill>
+                <a:latin typeface="Malgun Gothic"/>
+              </a:defRPr>
+            </a:pPr>
+            <a:r>
+              <a:t>• 피평가자와 동일 계열사 심사위원을 제외하는 '이해상충 방지' 기능</a:t>
+            </a:r>
+          </a:p>
+          <a:p>
+            <a:pPr>
+              <a:spcAft>
+                <a:spcPts val="600"/>
+              </a:spcAft>
+              <a:defRPr sz="1200">
+                <a:solidFill>
+                  <a:srgbClr val="94A3B8"/>
+                </a:solidFill>
+                <a:latin typeface="Malgun Gothic"/>
+              </a:defRPr>
+            </a:pPr>
+            <a:r>
+              <a:t>• 오른쪽 화면: 운영간사용 메인 관리 대시보드 및 평가 큐 상세 화면</a:t>
             </a:r>
           </a:p>
         </p:txBody>
@@ -4023,8 +3908,8 @@
         </p:nvSpPr>
         <p:spPr>
           <a:xfrm>
-            <a:off x="6309360" y="1828800"/>
-            <a:ext cx="5303520" cy="4114800"/>
+            <a:off x="6400800" y="1828800"/>
+            <a:ext cx="5212080" cy="4114800"/>
           </a:xfrm>
           <a:prstGeom prst="roundRect">
             <a:avLst/>
@@ -4034,7 +3919,7 @@
           </a:solidFill>
           <a:ln w="19050">
             <a:solidFill>
-              <a:srgbClr val="10B981"/>
+              <a:srgbClr val="6366F1"/>
             </a:solidFill>
           </a:ln>
         </p:spPr>
@@ -4060,93 +3945,30 @@
           </a:p>
         </p:txBody>
       </p:sp>
-      <p:sp>
-        <p:nvSpPr>
-          <p:cNvPr id="8" name="TextBox 7"/>
-          <p:cNvSpPr txBox="1"/>
+      <p:pic>
+        <p:nvPicPr>
+          <p:cNvPr id="8" name="Picture 7" descr="media__1784188798650.png"/>
+          <p:cNvPicPr>
+            <a:picLocks noChangeAspect="1"/>
+          </p:cNvPicPr>
           <p:nvPr/>
-        </p:nvSpPr>
-        <p:spPr>
-          <a:xfrm>
-            <a:off x="6446520" y="1965960"/>
-            <a:ext cx="5029200" cy="3840480"/>
+        </p:nvPicPr>
+        <p:blipFill>
+          <a:blip r:embed="rId2"/>
+          <a:stretch>
+            <a:fillRect/>
+          </a:stretch>
+        </p:blipFill>
+        <p:spPr>
+          <a:xfrm>
+            <a:off x="7369320" y="1965960"/>
+            <a:ext cx="3275038" cy="3840480"/>
           </a:xfrm>
           <a:prstGeom prst="rect">
             <a:avLst/>
           </a:prstGeom>
-          <a:noFill/>
-        </p:spPr>
-        <p:txBody>
-          <a:bodyPr wrap="square">
-            <a:spAutoFit/>
-          </a:bodyPr>
-          <a:lstStyle/>
-          <a:p>
-            <a:pPr>
-              <a:spcAft>
-                <a:spcPts val="1000"/>
-              </a:spcAft>
-              <a:defRPr sz="1500" b="1">
-                <a:solidFill>
-                  <a:srgbClr val="10B981"/>
-                </a:solidFill>
-                <a:latin typeface="Malgun Gothic"/>
-              </a:defRPr>
-            </a:pPr>
-            <a:r>
-              <a:t>대시보드 모니터링</a:t>
-            </a:r>
-          </a:p>
-          <a:p>
-            <a:pPr>
-              <a:spcAft>
-                <a:spcPts val="600"/>
-              </a:spcAft>
-              <a:defRPr sz="1200">
-                <a:solidFill>
-                  <a:srgbClr val="94A3B8"/>
-                </a:solidFill>
-                <a:latin typeface="Malgun Gothic"/>
-              </a:defRPr>
-            </a:pPr>
-            <a:r>
-              <a:t>• 4대 통계 카드: 전체 지원자 수, 평가 완료, 진행중, 대기 건수 모니터링</a:t>
-            </a:r>
-          </a:p>
-          <a:p>
-            <a:pPr>
-              <a:spcAft>
-                <a:spcPts val="600"/>
-              </a:spcAft>
-              <a:defRPr sz="1200">
-                <a:solidFill>
-                  <a:srgbClr val="94A3B8"/>
-                </a:solidFill>
-                <a:latin typeface="Malgun Gothic"/>
-              </a:defRPr>
-            </a:pPr>
-            <a:r>
-              <a:t>• 상세 모달 조회: 통계 카드를 클릭하면 해당 그룹(예: '평가 대기')의 지원자 상세 정보 및 담당 심사위원의 실시간 진행 현황 팝업 조회</a:t>
-            </a:r>
-          </a:p>
-          <a:p>
-            <a:pPr>
-              <a:spcAft>
-                <a:spcPts val="600"/>
-              </a:spcAft>
-              <a:defRPr sz="1200">
-                <a:solidFill>
-                  <a:srgbClr val="94A3B8"/>
-                </a:solidFill>
-                <a:latin typeface="Malgun Gothic"/>
-              </a:defRPr>
-            </a:pPr>
-            <a:r>
-              <a:t>• 소속 관계사별(에이텍모빌리티, 에이텍씨앤 등) 및 인증 레벨별 정교한 필터링 제공</a:t>
-            </a:r>
-          </a:p>
-        </p:txBody>
-      </p:sp>
+        </p:spPr>
+      </p:pic>
     </p:spTree>
   </p:cSld>
   <p:clrMapOvr>
@@ -4240,7 +4062,7 @@
               </a:defRPr>
             </a:pPr>
             <a:r>
-              <a:t>3. 심사위원 가이드 (Reviewer Workspace)</a:t>
+              <a:t>3. 심사위원 가이드 (Reviewer Evaluation)</a:t>
             </a:r>
           </a:p>
         </p:txBody>
@@ -4299,7 +4121,7 @@
         <p:spPr>
           <a:xfrm>
             <a:off x="548640" y="1828800"/>
-            <a:ext cx="5303520" cy="4114800"/>
+            <a:ext cx="5486400" cy="4114800"/>
           </a:xfrm>
           <a:prstGeom prst="roundRect">
             <a:avLst/>
@@ -4344,7 +4166,7 @@
         <p:spPr>
           <a:xfrm>
             <a:off x="685800" y="1965960"/>
-            <a:ext cx="5029200" cy="3840480"/>
+            <a:ext cx="5212080" cy="3840480"/>
           </a:xfrm>
           <a:prstGeom prst="rect">
             <a:avLst/>
@@ -4369,7 +4191,7 @@
               </a:defRPr>
             </a:pPr>
             <a:r>
-              <a:t>개인 심사 큐 및 5단계 루브릭 채점</a:t>
+              <a:t>5단계 세로형 루브릭 채점 및 질문은행</a:t>
             </a:r>
           </a:p>
           <a:p>
@@ -4385,7 +4207,7 @@
               </a:defRPr>
             </a:pPr>
             <a:r>
-              <a:t>• 본인의 성명(ID)과 이메일(PW)을 입력하여 시스템 로그인</a:t>
+              <a:t>• 본인에게 배정된 과제 큐에서 [심사하기]를 클릭하여 진입</a:t>
             </a:r>
           </a:p>
           <a:p>
@@ -4401,7 +4223,11 @@
               </a:defRPr>
             </a:pPr>
             <a:r>
-              <a:t>• 자신에게 배정된 과제 큐에서 [심사하기] 버튼 선택</a:t>
+              <a:t>• 난이도/완성도/자산화(기술/보안/기여)별 5단계 채점 등급 선택:</a:t>
+            </a:r>
+            <a:br/>
+            <a:r>
+              <a:t>(탁월 100, 양호 85, 보통 70, 미흡 50, 부족 30)</a:t>
             </a:r>
           </a:p>
           <a:p>
@@ -4417,11 +4243,7 @@
               </a:defRPr>
             </a:pPr>
             <a:r>
-              <a:t>• 기존 3단계에서 확장된 '5단계 루브릭' 채점 지원:</a:t>
-            </a:r>
-            <a:br/>
-            <a:r>
-              <a:t>(탁월: 100, 양호: 85, 보통: 70, 미흡: 50, 부족: 30)</a:t>
+              <a:t>• 각 등급별 정성/정량적 세부 텍스트 설명 렌더링으로 객관성 확보</a:t>
             </a:r>
           </a:p>
           <a:p>
@@ -4437,7 +4259,23 @@
               </a:defRPr>
             </a:pPr>
             <a:r>
-              <a:t>• 세로 스택 행 레이아웃으로 개편하여 루브릭 상세 설명서의 텍스트 가독성 최적화</a:t>
+              <a:t>• 과제 카테고리별 맞춤 질문은행 도우미 탑재 (질문 검색 기능 포함)</a:t>
+            </a:r>
+          </a:p>
+          <a:p>
+            <a:pPr>
+              <a:spcAft>
+                <a:spcPts val="600"/>
+              </a:spcAft>
+              <a:defRPr sz="1200">
+                <a:solidFill>
+                  <a:srgbClr val="94A3B8"/>
+                </a:solidFill>
+                <a:latin typeface="Malgun Gothic"/>
+              </a:defRPr>
+            </a:pPr>
+            <a:r>
+              <a:t>• 오른쪽 화면: 심사위원 점수 입력 및 보안 체크리스트 작업 화면</a:t>
             </a:r>
           </a:p>
         </p:txBody>
@@ -4450,8 +4288,8 @@
         </p:nvSpPr>
         <p:spPr>
           <a:xfrm>
-            <a:off x="6309360" y="1828800"/>
-            <a:ext cx="5303520" cy="4114800"/>
+            <a:off x="6400800" y="1828800"/>
+            <a:ext cx="5212080" cy="4114800"/>
           </a:xfrm>
           <a:prstGeom prst="roundRect">
             <a:avLst/>
@@ -4461,7 +4299,7 @@
           </a:solidFill>
           <a:ln w="19050">
             <a:solidFill>
-              <a:srgbClr val="10B981"/>
+              <a:srgbClr val="6366F1"/>
             </a:solidFill>
           </a:ln>
         </p:spPr>
@@ -4487,93 +4325,30 @@
           </a:p>
         </p:txBody>
       </p:sp>
-      <p:sp>
-        <p:nvSpPr>
-          <p:cNvPr id="8" name="TextBox 7"/>
-          <p:cNvSpPr txBox="1"/>
+      <p:pic>
+        <p:nvPicPr>
+          <p:cNvPr id="8" name="Picture 7" descr="media__1784176902473.png"/>
+          <p:cNvPicPr>
+            <a:picLocks noChangeAspect="1"/>
+          </p:cNvPicPr>
           <p:nvPr/>
-        </p:nvSpPr>
-        <p:spPr>
-          <a:xfrm>
-            <a:off x="6446520" y="1965960"/>
-            <a:ext cx="5029200" cy="3840480"/>
+        </p:nvPicPr>
+        <p:blipFill>
+          <a:blip r:embed="rId2"/>
+          <a:stretch>
+            <a:fillRect/>
+          </a:stretch>
+        </p:blipFill>
+        <p:spPr>
+          <a:xfrm>
+            <a:off x="6814049" y="1965960"/>
+            <a:ext cx="4385580" cy="3840480"/>
           </a:xfrm>
           <a:prstGeom prst="rect">
             <a:avLst/>
           </a:prstGeom>
-          <a:noFill/>
-        </p:spPr>
-        <p:txBody>
-          <a:bodyPr wrap="square">
-            <a:spAutoFit/>
-          </a:bodyPr>
-          <a:lstStyle/>
-          <a:p>
-            <a:pPr>
-              <a:spcAft>
-                <a:spcPts val="1000"/>
-              </a:spcAft>
-              <a:defRPr sz="1500" b="1">
-                <a:solidFill>
-                  <a:srgbClr val="10B981"/>
-                </a:solidFill>
-                <a:latin typeface="Malgun Gothic"/>
-              </a:defRPr>
-            </a:pPr>
-            <a:r>
-              <a:t>면접 도우미 및 합의 판정</a:t>
-            </a:r>
-          </a:p>
-          <a:p>
-            <a:pPr>
-              <a:spcAft>
-                <a:spcPts val="600"/>
-              </a:spcAft>
-              <a:defRPr sz="1200">
-                <a:solidFill>
-                  <a:srgbClr val="94A3B8"/>
-                </a:solidFill>
-                <a:latin typeface="Malgun Gothic"/>
-              </a:defRPr>
-            </a:pPr>
-            <a:r>
-              <a:t>• 질문은행 (Question Bank): 과제 성격(RAG, 업무자동화 등)에 따라 적절한 면접 질문을 바로 검색하여 질문 구성 보조</a:t>
-            </a:r>
-          </a:p>
-          <a:p>
-            <a:pPr>
-              <a:spcAft>
-                <a:spcPts val="600"/>
-              </a:spcAft>
-              <a:defRPr sz="1200">
-                <a:solidFill>
-                  <a:srgbClr val="94A3B8"/>
-                </a:solidFill>
-                <a:latin typeface="Malgun Gothic"/>
-              </a:defRPr>
-            </a:pPr>
-            <a:r>
-              <a:t>• Consensus Monitor: 심사위원들 사이의 최종 점수 편차가 15점 이상일 경우 의견 조율 알림 및 합의서 유도</a:t>
-            </a:r>
-          </a:p>
-          <a:p>
-            <a:pPr>
-              <a:spcAft>
-                <a:spcPts val="600"/>
-              </a:spcAft>
-              <a:defRPr sz="1200">
-                <a:solidFill>
-                  <a:srgbClr val="94A3B8"/>
-                </a:solidFill>
-                <a:latin typeface="Malgun Gothic"/>
-              </a:defRPr>
-            </a:pPr>
-            <a:r>
-              <a:t>• 평가 완료 및 제출 클릭 시 실시간 클라우드 DB 연동</a:t>
-            </a:r>
-          </a:p>
-        </p:txBody>
-      </p:sp>
+        </p:spPr>
+      </p:pic>
     </p:spTree>
   </p:cSld>
   <p:clrMapOvr>
@@ -4726,7 +4501,7 @@
         <p:spPr>
           <a:xfrm>
             <a:off x="548640" y="1828800"/>
-            <a:ext cx="5303520" cy="4114800"/>
+            <a:ext cx="5486400" cy="4114800"/>
           </a:xfrm>
           <a:prstGeom prst="roundRect">
             <a:avLst/>
@@ -4736,7 +4511,7 @@
           </a:solidFill>
           <a:ln w="19050">
             <a:solidFill>
-              <a:srgbClr val="10B981"/>
+              <a:srgbClr val="6366F1"/>
             </a:solidFill>
           </a:ln>
         </p:spPr>
@@ -4771,7 +4546,7 @@
         <p:spPr>
           <a:xfrm>
             <a:off x="685800" y="1965960"/>
-            <a:ext cx="5029200" cy="3840480"/>
+            <a:ext cx="5212080" cy="3840480"/>
           </a:xfrm>
           <a:prstGeom prst="rect">
             <a:avLst/>
@@ -4790,13 +4565,13 @@
               </a:spcAft>
               <a:defRPr sz="1500" b="1">
                 <a:solidFill>
-                  <a:srgbClr val="10B981"/>
+                  <a:srgbClr val="6366F1"/>
                 </a:solidFill>
                 <a:latin typeface="Malgun Gothic"/>
               </a:defRPr>
             </a:pPr>
             <a:r>
-              <a:t>자격인증 심사결과 종합판정서 출력</a:t>
+              <a:t>인쇄 최적화 보고서 출력 및 서명 동기화</a:t>
             </a:r>
           </a:p>
           <a:p>
@@ -4812,7 +4587,7 @@
               </a:defRPr>
             </a:pPr>
             <a:r>
-              <a:t>• 3인의 심사가 모두 완료되면 [보고서 보기] 버튼 활성화</a:t>
+              <a:t>• 3인 평가 점수가 모두 제출되면 종합 판정 결과가 자동 집계 및 승인</a:t>
             </a:r>
           </a:p>
           <a:p>
@@ -4828,7 +4603,7 @@
               </a:defRPr>
             </a:pPr>
             <a:r>
-              <a:t>• 종합 판정 요약: 합격/보완후합격/불합격의 실시간 최종 판정 제공</a:t>
+              <a:t>• A4 표준 비율 레이아웃 및 브라우저 프린트 내보내기 최적화 지원</a:t>
             </a:r>
           </a:p>
           <a:p>
@@ -4844,7 +4619,7 @@
               </a:defRPr>
             </a:pPr>
             <a:r>
-              <a:t>• 심사위원별 세부 의견 및 감점 사유서 출력 최적화</a:t>
+              <a:t>• 하단 서명 명패: 임의의 홍길동 명패를 배정된 심사위원 이름으로 자동 변경 완료</a:t>
             </a:r>
           </a:p>
           <a:p>
@@ -4860,7 +4635,23 @@
               </a:defRPr>
             </a:pPr>
             <a:r>
-              <a:t>• 서명란 동기화: 임의의 홍길동 서명 명패를 실제 평가를 진행한 3인 심사위원 성명으로 실시간 자동 매핑 완료</a:t>
+              <a:t>• Firebase Cloud DB 연동을 통한 영속적 평가 정보 자동 관리</a:t>
+            </a:r>
+          </a:p>
+          <a:p>
+            <a:pPr>
+              <a:spcAft>
+                <a:spcPts val="600"/>
+              </a:spcAft>
+              <a:defRPr sz="1200">
+                <a:solidFill>
+                  <a:srgbClr val="94A3B8"/>
+                </a:solidFill>
+                <a:latin typeface="Malgun Gothic"/>
+              </a:defRPr>
+            </a:pPr>
+            <a:r>
+              <a:t>• 오른쪽 화면: 서명이 실제 심사위원 성명으로 연동된 결과 보고서 하단부</a:t>
             </a:r>
           </a:p>
         </p:txBody>
@@ -4873,8 +4664,8 @@
         </p:nvSpPr>
         <p:spPr>
           <a:xfrm>
-            <a:off x="6309360" y="1828800"/>
-            <a:ext cx="5303520" cy="4114800"/>
+            <a:off x="6400800" y="1828800"/>
+            <a:ext cx="5212080" cy="4114800"/>
           </a:xfrm>
           <a:prstGeom prst="roundRect">
             <a:avLst/>
@@ -4910,93 +4701,30 @@
           </a:p>
         </p:txBody>
       </p:sp>
-      <p:sp>
-        <p:nvSpPr>
-          <p:cNvPr id="8" name="TextBox 7"/>
-          <p:cNvSpPr txBox="1"/>
+      <p:pic>
+        <p:nvPicPr>
+          <p:cNvPr id="8" name="Picture 7" descr="media__1784596287593.png"/>
+          <p:cNvPicPr>
+            <a:picLocks noChangeAspect="1"/>
+          </p:cNvPicPr>
           <p:nvPr/>
-        </p:nvSpPr>
-        <p:spPr>
-          <a:xfrm>
-            <a:off x="6446520" y="1965960"/>
-            <a:ext cx="5029200" cy="3840480"/>
+        </p:nvPicPr>
+        <p:blipFill>
+          <a:blip r:embed="rId2"/>
+          <a:stretch>
+            <a:fillRect/>
+          </a:stretch>
+        </p:blipFill>
+        <p:spPr>
+          <a:xfrm>
+            <a:off x="7059982" y="1965960"/>
+            <a:ext cx="3893714" cy="3840480"/>
           </a:xfrm>
           <a:prstGeom prst="rect">
             <a:avLst/>
           </a:prstGeom>
-          <a:noFill/>
-        </p:spPr>
-        <p:txBody>
-          <a:bodyPr wrap="square">
-            <a:spAutoFit/>
-          </a:bodyPr>
-          <a:lstStyle/>
-          <a:p>
-            <a:pPr>
-              <a:spcAft>
-                <a:spcPts val="1000"/>
-              </a:spcAft>
-              <a:defRPr sz="1500" b="1">
-                <a:solidFill>
-                  <a:srgbClr val="6366F1"/>
-                </a:solidFill>
-                <a:latin typeface="Malgun Gothic"/>
-              </a:defRPr>
-            </a:pPr>
-            <a:r>
-              <a:t>Firebase Firestore 실시간 데이터베이스</a:t>
-            </a:r>
-          </a:p>
-          <a:p>
-            <a:pPr>
-              <a:spcAft>
-                <a:spcPts val="600"/>
-              </a:spcAft>
-              <a:defRPr sz="1200">
-                <a:solidFill>
-                  <a:srgbClr val="94A3B8"/>
-                </a:solidFill>
-                <a:latin typeface="Malgun Gothic"/>
-              </a:defRPr>
-            </a:pPr>
-            <a:r>
-              <a:t>• 이관 완료: 로컬 메모리 저장 방식에서 NoSQL 클라우드 DB 연동으로 개편 완료</a:t>
-            </a:r>
-          </a:p>
-          <a:p>
-            <a:pPr>
-              <a:spcAft>
-                <a:spcPts val="600"/>
-              </a:spcAft>
-              <a:defRPr sz="1200">
-                <a:solidFill>
-                  <a:srgbClr val="94A3B8"/>
-                </a:solidFill>
-                <a:latin typeface="Malgun Gothic"/>
-              </a:defRPr>
-            </a:pPr>
-            <a:r>
-              <a:t>• 데이터 보존: 서버나 브라우저 재부팅 시에도 평가 데이터가 영구 보존</a:t>
-            </a:r>
-          </a:p>
-          <a:p>
-            <a:pPr>
-              <a:spcAft>
-                <a:spcPts val="600"/>
-              </a:spcAft>
-              <a:defRPr sz="1200">
-                <a:solidFill>
-                  <a:srgbClr val="94A3B8"/>
-                </a:solidFill>
-                <a:latin typeface="Malgun Gothic"/>
-              </a:defRPr>
-            </a:pPr>
-            <a:r>
-              <a:t>• 다중 사용자 동시 접속 시 심사 진행율 및 LED 램프 배지가 새로고침 없이 실시간 변화</a:t>
-            </a:r>
-          </a:p>
-        </p:txBody>
-      </p:sp>
+        </p:spPr>
+      </p:pic>
     </p:spTree>
   </p:cSld>
   <p:clrMapOvr>
@@ -5090,7 +4818,7 @@
               </a:defRPr>
             </a:pPr>
             <a:r>
-              <a:t>5. 서버 배포 및 기동 가이드</a:t>
+              <a:t>5. 서버 배포 및 구동 가이드</a:t>
             </a:r>
           </a:p>
         </p:txBody>
@@ -5149,7 +4877,7 @@
         <p:spPr>
           <a:xfrm>
             <a:off x="548640" y="1828800"/>
-            <a:ext cx="5303520" cy="4114800"/>
+            <a:ext cx="5486400" cy="4114800"/>
           </a:xfrm>
           <a:prstGeom prst="roundRect">
             <a:avLst/>
@@ -5159,7 +4887,7 @@
           </a:solidFill>
           <a:ln w="19050">
             <a:solidFill>
-              <a:srgbClr val="10B981"/>
+              <a:srgbClr val="6366F1"/>
             </a:solidFill>
           </a:ln>
         </p:spPr>
@@ -5194,7 +4922,7 @@
         <p:spPr>
           <a:xfrm>
             <a:off x="685800" y="1965960"/>
-            <a:ext cx="5029200" cy="3840480"/>
+            <a:ext cx="5212080" cy="3840480"/>
           </a:xfrm>
           <a:prstGeom prst="rect">
             <a:avLst/>
@@ -5213,13 +4941,13 @@
               </a:spcAft>
               <a:defRPr sz="1500" b="1">
                 <a:solidFill>
-                  <a:srgbClr val="10B981"/>
+                  <a:srgbClr val="6366F1"/>
                 </a:solidFill>
                 <a:latin typeface="Malgun Gothic"/>
               </a:defRPr>
             </a:pPr>
             <a:r>
-              <a:t>로컬 PC 웹 서버 실행 방법</a:t>
+              <a:t>로컬 구동, Docker 및 Windows IIS 지원</a:t>
             </a:r>
           </a:p>
           <a:p>
@@ -5235,7 +4963,7 @@
               </a:defRPr>
             </a:pPr>
             <a:r>
-              <a:t>• Vite 환경 변수 파일 생성: .env.local을 만들어 Firebase API Key 기입 (누락 시 테스트용 Mock 데이터베이스 자동 작동)</a:t>
+              <a:t>• Node.js 무설치 프로덕션 웹 서버(server.js) 실행 (포트 8080)</a:t>
             </a:r>
           </a:p>
           <a:p>
@@ -5251,7 +4979,7 @@
               </a:defRPr>
             </a:pPr>
             <a:r>
-              <a:t>• 빌드 패키지 생성: `npm run build` 실행</a:t>
+              <a:t>• Docker 빌드: `Dockerfile` 및 `nginx.conf` 구성으로 Nginx 컨테이너 기동</a:t>
             </a:r>
           </a:p>
           <a:p>
@@ -5267,7 +4995,7 @@
               </a:defRPr>
             </a:pPr>
             <a:r>
-              <a:t>• 경량 서버 구동: `node server.js` 입력</a:t>
+              <a:t>• Windows IIS: `web.config.example` 템플릿 제공으로 SPA URL 리라우팅 최적화</a:t>
             </a:r>
           </a:p>
           <a:p>
@@ -5283,7 +5011,7 @@
               </a:defRPr>
             </a:pPr>
             <a:r>
-              <a:t>• 접속 주소: http://localhost:8080 (내부 IP 사용 시 사내 로컬망 공유 가능)</a:t>
+              <a:t>• Vite 개발 모드 힌트 박스 자동 배제로 프로덕션 소스코드 보안 유지</a:t>
             </a:r>
           </a:p>
           <a:p>
@@ -5299,7 +5027,7 @@
               </a:defRPr>
             </a:pPr>
             <a:r>
-              <a:t>• Vite 개발 모드 힌트 박스는 빌드 시 소스코드에서 자동 배제되어 보안 유지</a:t>
+              <a:t>• 오른쪽 화면: 로컬 개발 서버 동작 및 핫 모듈 리플레이스먼트 모니터</a:t>
             </a:r>
           </a:p>
         </p:txBody>
@@ -5312,8 +5040,8 @@
         </p:nvSpPr>
         <p:spPr>
           <a:xfrm>
-            <a:off x="6309360" y="1828800"/>
-            <a:ext cx="5303520" cy="4114800"/>
+            <a:off x="6400800" y="1828800"/>
+            <a:ext cx="5212080" cy="4114800"/>
           </a:xfrm>
           <a:prstGeom prst="roundRect">
             <a:avLst/>
@@ -5349,93 +5077,30 @@
           </a:p>
         </p:txBody>
       </p:sp>
-      <p:sp>
-        <p:nvSpPr>
-          <p:cNvPr id="8" name="TextBox 7"/>
-          <p:cNvSpPr txBox="1"/>
+      <p:pic>
+        <p:nvPicPr>
+          <p:cNvPr id="8" name="Picture 7" descr="media__1784176101924.png"/>
+          <p:cNvPicPr>
+            <a:picLocks noChangeAspect="1"/>
+          </p:cNvPicPr>
           <p:nvPr/>
-        </p:nvSpPr>
-        <p:spPr>
-          <a:xfrm>
-            <a:off x="6446520" y="1965960"/>
-            <a:ext cx="5029200" cy="3840480"/>
+        </p:nvPicPr>
+        <p:blipFill>
+          <a:blip r:embed="rId2"/>
+          <a:stretch>
+            <a:fillRect/>
+          </a:stretch>
+        </p:blipFill>
+        <p:spPr>
+          <a:xfrm>
+            <a:off x="6537960" y="2398922"/>
+            <a:ext cx="4937760" cy="2974554"/>
           </a:xfrm>
           <a:prstGeom prst="rect">
             <a:avLst/>
           </a:prstGeom>
-          <a:noFill/>
-        </p:spPr>
-        <p:txBody>
-          <a:bodyPr wrap="square">
-            <a:spAutoFit/>
-          </a:bodyPr>
-          <a:lstStyle/>
-          <a:p>
-            <a:pPr>
-              <a:spcAft>
-                <a:spcPts val="1000"/>
-              </a:spcAft>
-              <a:defRPr sz="1500" b="1">
-                <a:solidFill>
-                  <a:srgbClr val="6366F1"/>
-                </a:solidFill>
-                <a:latin typeface="Malgun Gothic"/>
-              </a:defRPr>
-            </a:pPr>
-            <a:r>
-              <a:t>서버 가상화 및 IIS 웹 서버 배포</a:t>
-            </a:r>
-          </a:p>
-          <a:p>
-            <a:pPr>
-              <a:spcAft>
-                <a:spcPts val="600"/>
-              </a:spcAft>
-              <a:defRPr sz="1200">
-                <a:solidFill>
-                  <a:srgbClr val="94A3B8"/>
-                </a:solidFill>
-                <a:latin typeface="Malgun Gothic"/>
-              </a:defRPr>
-            </a:pPr>
-            <a:r>
-              <a:t>• Docker 배포:</a:t>
-            </a:r>
-            <a:br/>
-            <a:r>
-              <a:t>  Dockerfile 및 nginx.conf 구성을 이용해 초경량 Nginx 컨테이너 제작 구동 (SPA 라우팅 지원)</a:t>
-            </a:r>
-            <a:br/>
-            <a:r>
-              <a:t>  `docker build -t aica-app .` 실행</a:t>
-            </a:r>
-          </a:p>
-          <a:p>
-            <a:pPr>
-              <a:spcAft>
-                <a:spcPts val="600"/>
-              </a:spcAft>
-              <a:defRPr sz="1200">
-                <a:solidFill>
-                  <a:srgbClr val="94A3B8"/>
-                </a:solidFill>
-                <a:latin typeface="Malgun Gothic"/>
-              </a:defRPr>
-            </a:pPr>
-            <a:r>
-              <a:t>• Windows IIS 서버 배포:</a:t>
-            </a:r>
-            <a:br/>
-            <a:r>
-              <a:t>  물리적 배포 경로 설정 후 URL Rewrite 설치</a:t>
-            </a:r>
-            <a:br/>
-            <a:r>
-              <a:t>  제공된 `web.config.example` 템플릿의 rewrite 규칙을 덮어씌워 404 라우팅 오류 제어</a:t>
-            </a:r>
-          </a:p>
-        </p:txBody>
-      </p:sp>
+        </p:spPr>
+      </p:pic>
     </p:spTree>
   </p:cSld>
   <p:clrMapOvr>

</xml_diff>

<commit_message>
feat: add Simulation Data Load and Data Reset controls to Admin Dashboard for Firebase/Local DB
</commit_message>
<xml_diff>
--- a/AICA_System_User_Manual.pptx
+++ b/AICA_System_User_Manual.pptx
@@ -8539,55 +8539,71 @@
               </a:defRPr>
             </a:pPr>
             <a:r>
-              <a:t>1. 요약 지표: 전체, 완료, 진행 중, 대기 인원을 실시간 확인</a:t>
-            </a:r>
-          </a:p>
-          <a:p>
-            <a:pPr>
-              <a:spcAft>
-                <a:spcPts val="600"/>
-              </a:spcAft>
-              <a:defRPr sz="1100">
-                <a:solidFill>
-                  <a:srgbClr val="94A3B8"/>
-                </a:solidFill>
-                <a:latin typeface="Noto Sans KR"/>
-              </a:defRPr>
-            </a:pPr>
-            <a:r>
-              <a:t>2. 관계사 평균: 완료된 심사를 기준으로 계열사별 평균 점수를 모니터링</a:t>
-            </a:r>
-          </a:p>
-          <a:p>
-            <a:pPr>
-              <a:spcAft>
-                <a:spcPts val="600"/>
-              </a:spcAft>
-              <a:defRPr sz="1100">
-                <a:solidFill>
-                  <a:srgbClr val="94A3B8"/>
-                </a:solidFill>
-                <a:latin typeface="Noto Sans KR"/>
-              </a:defRPr>
-            </a:pPr>
-            <a:r>
-              <a:t>3. 평가 기준: L3/L4 가중치와 치명적 결격 기준을 확인</a:t>
-            </a:r>
-          </a:p>
-          <a:p>
-            <a:pPr>
-              <a:spcAft>
-                <a:spcPts val="600"/>
-              </a:spcAft>
-              <a:defRPr sz="1100">
-                <a:solidFill>
-                  <a:srgbClr val="94A3B8"/>
-                </a:solidFill>
-                <a:latin typeface="Noto Sans KR"/>
-              </a:defRPr>
-            </a:pPr>
-            <a:r>
-              <a:t>4. 전체 큐: 필터와 액션을 통한 개별 심사 통합 관리</a:t>
+              <a:t>1. 시뮬레이션 데이터 불러오기: 가상의 테스트 데이터셋(후보자 9명 및 3인 패널 평가 결과) 복원</a:t>
+            </a:r>
+          </a:p>
+          <a:p>
+            <a:pPr>
+              <a:spcAft>
+                <a:spcPts val="600"/>
+              </a:spcAft>
+              <a:defRPr sz="1100">
+                <a:solidFill>
+                  <a:srgbClr val="94A3B8"/>
+                </a:solidFill>
+                <a:latin typeface="Noto Sans KR"/>
+              </a:defRPr>
+            </a:pPr>
+            <a:r>
+              <a:t>2. 데이터 초기화: 실무 운영 착수를 위해 전체 평가 과제 및 결과를 깨끗하게 초기화</a:t>
+            </a:r>
+          </a:p>
+          <a:p>
+            <a:pPr>
+              <a:spcAft>
+                <a:spcPts val="600"/>
+              </a:spcAft>
+              <a:defRPr sz="1100">
+                <a:solidFill>
+                  <a:srgbClr val="94A3B8"/>
+                </a:solidFill>
+                <a:latin typeface="Noto Sans KR"/>
+              </a:defRPr>
+            </a:pPr>
+            <a:r>
+              <a:t>3. 요약 지표: 전체, 완료, 진행 중, 대기 인원을 실시간 확인 (클릭 시 명단 모달 팝업)</a:t>
+            </a:r>
+          </a:p>
+          <a:p>
+            <a:pPr>
+              <a:spcAft>
+                <a:spcPts val="600"/>
+              </a:spcAft>
+              <a:defRPr sz="1100">
+                <a:solidFill>
+                  <a:srgbClr val="94A3B8"/>
+                </a:solidFill>
+                <a:latin typeface="Noto Sans KR"/>
+              </a:defRPr>
+            </a:pPr>
+            <a:r>
+              <a:t>4. 관계사 평균: 완료된 심사를 기준으로 계열사별 평균 점수를 모니터링</a:t>
+            </a:r>
+          </a:p>
+          <a:p>
+            <a:pPr>
+              <a:spcAft>
+                <a:spcPts val="600"/>
+              </a:spcAft>
+              <a:defRPr sz="1100">
+                <a:solidFill>
+                  <a:srgbClr val="94A3B8"/>
+                </a:solidFill>
+                <a:latin typeface="Noto Sans KR"/>
+              </a:defRPr>
+            </a:pPr>
+            <a:r>
+              <a:t>5. 전체 큐: 필터와 액션을 통한 개별 심사 통합 관리</a:t>
             </a:r>
           </a:p>
           <a:p>
@@ -8604,7 +8620,7 @@
               </a:defRPr>
             </a:pPr>
             <a:r>
-              <a:t>💡 명단 보기 기능: 각 지표(통계 카드) 클릭 시 해당 대상자 목록을 모달 팝업으로 즉시 확인할 수 있습니다.</a:t>
+              <a:t>💡 대시보드 우측 상단 배지를 통해 테스트 시연용 가상 데이터 복원 및 실무용 초기화를 손쉽게 제어할 수 있습니다.</a:t>
             </a:r>
           </a:p>
           <a:p>

</xml_diff>

<commit_message>
feat: implement Monthly Evaluation Calendar and explicit date metadata across reports
</commit_message>
<xml_diff>
--- a/AICA_System_User_Manual.pptx
+++ b/AICA_System_User_Manual.pptx
@@ -21,6 +21,7 @@
     <p:sldId id="269" r:id="rId20"/>
     <p:sldId id="270" r:id="rId21"/>
     <p:sldId id="271" r:id="rId22"/>
+    <p:sldId id="272" r:id="rId23"/>
   </p:sldIdLst>
   <p:sldSz cx="12191695" cy="6858000" type="screen4x3"/>
   <p:notesSz cx="6858000" cy="9144000"/>
@@ -3409,7 +3410,7 @@
               </a:defRPr>
             </a:pPr>
             <a:r>
-              <a:t>심사위원</a:t>
+              <a:t>운영간사</a:t>
             </a:r>
           </a:p>
         </p:txBody>
@@ -3445,7 +3446,7 @@
               </a:defRPr>
             </a:pPr>
             <a:r>
-              <a:t>내 배정 과제 큐에서 심사 우선순위를 잡습니다</a:t>
+              <a:t>3인 제출 후 종합판정서가 완성됩니다</a:t>
             </a:r>
           </a:p>
         </p:txBody>
@@ -3560,7 +3561,7 @@
               </a:defRPr>
             </a:pPr>
             <a:r>
-              <a:t>10</a:t>
+              <a:t>09</a:t>
             </a:r>
           </a:p>
         </p:txBody>
@@ -3644,55 +3645,87 @@
               </a:defRPr>
             </a:pPr>
             <a:r>
-              <a:t>심사 위원 배정 큐 모니터링</a:t>
-            </a:r>
-          </a:p>
-          <a:p>
-            <a:pPr>
-              <a:spcAft>
-                <a:spcPts val="600"/>
-              </a:spcAft>
-              <a:defRPr sz="1100">
-                <a:solidFill>
-                  <a:srgbClr val="94A3B8"/>
-                </a:solidFill>
-                <a:latin typeface="Noto Sans KR"/>
-              </a:defRPr>
-            </a:pPr>
-            <a:r>
-              <a:t>심사위원 전용 배정 과제 리스트 가이드:</a:t>
-            </a:r>
-          </a:p>
-          <a:p>
-            <a:pPr>
-              <a:spcAft>
-                <a:spcPts val="600"/>
-              </a:spcAft>
-              <a:defRPr sz="1100">
-                <a:solidFill>
-                  <a:srgbClr val="94A3B8"/>
-                </a:solidFill>
-                <a:latin typeface="Noto Sans KR"/>
-              </a:defRPr>
-            </a:pPr>
-            <a:r>
-              <a:t>• 성명 및 이메일 로그인 시, 본인이 패널로 등록된 평가 과제만 화면에 정렬됩니다.</a:t>
-            </a:r>
-          </a:p>
-          <a:p>
-            <a:pPr>
-              <a:spcAft>
-                <a:spcPts val="600"/>
-              </a:spcAft>
-              <a:defRPr sz="1100">
-                <a:solidFill>
-                  <a:srgbClr val="94A3B8"/>
-                </a:solidFill>
-                <a:latin typeface="Noto Sans KR"/>
-              </a:defRPr>
-            </a:pPr>
-            <a:r>
-              <a:t>• 테이블 컬럼: 지원자 정보, 소속 법인/부서, 자격 인증 레벨, 내 평가 진행 현황(대기/완료), 타 위원 제출 진척 상태 배지 표시</a:t>
+              <a:t>종합판정 보고서 발급 및 명패 동기화</a:t>
+            </a:r>
+          </a:p>
+          <a:p>
+            <a:pPr>
+              <a:spcAft>
+                <a:spcPts val="600"/>
+              </a:spcAft>
+              <a:defRPr sz="1100">
+                <a:solidFill>
+                  <a:srgbClr val="94A3B8"/>
+                </a:solidFill>
+                <a:latin typeface="Noto Sans KR"/>
+              </a:defRPr>
+            </a:pPr>
+            <a:r>
+              <a:t>종합판정서 구성 항목 및 검증 가이드:</a:t>
+            </a:r>
+          </a:p>
+          <a:p>
+            <a:pPr>
+              <a:spcAft>
+                <a:spcPts val="600"/>
+              </a:spcAft>
+              <a:defRPr sz="1100">
+                <a:solidFill>
+                  <a:srgbClr val="94A3B8"/>
+                </a:solidFill>
+                <a:latin typeface="Noto Sans KR"/>
+              </a:defRPr>
+            </a:pPr>
+            <a:r>
+              <a:t>• 지원자 기본 정보 및 종합 평균 점수 시각화</a:t>
+            </a:r>
+          </a:p>
+          <a:p>
+            <a:pPr>
+              <a:spcAft>
+                <a:spcPts val="600"/>
+              </a:spcAft>
+              <a:defRPr sz="1100">
+                <a:solidFill>
+                  <a:srgbClr val="94A3B8"/>
+                </a:solidFill>
+                <a:latin typeface="Noto Sans KR"/>
+              </a:defRPr>
+            </a:pPr>
+            <a:r>
+              <a:t>• 3인 배정 위원의 세부 루브릭 채점 점수 및 종합 정성 평가 의견 노출</a:t>
+            </a:r>
+          </a:p>
+          <a:p>
+            <a:pPr>
+              <a:spcAft>
+                <a:spcPts val="600"/>
+              </a:spcAft>
+              <a:defRPr sz="1100">
+                <a:solidFill>
+                  <a:srgbClr val="94A3B8"/>
+                </a:solidFill>
+                <a:latin typeface="Noto Sans KR"/>
+              </a:defRPr>
+            </a:pPr>
+            <a:r>
+              <a:t>• 하단 서명란: 배정된 실제 심사위원 성명으로 명패 자동 변경 완료</a:t>
+            </a:r>
+          </a:p>
+          <a:p>
+            <a:pPr>
+              <a:spcAft>
+                <a:spcPts val="600"/>
+              </a:spcAft>
+              <a:defRPr sz="1100">
+                <a:solidFill>
+                  <a:srgbClr val="94A3B8"/>
+                </a:solidFill>
+                <a:latin typeface="Noto Sans KR"/>
+              </a:defRPr>
+            </a:pPr>
+            <a:r>
+              <a:t>• 출력 최적화: [결과 보고서 인쇄 (PDF)] 버튼을 클릭하여 A4 최적화 보고서 출력 및 사내 공유용 저장 가능</a:t>
             </a:r>
           </a:p>
           <a:p>
@@ -3709,23 +3742,23 @@
               </a:defRPr>
             </a:pPr>
             <a:r>
-              <a:t>[심사하기/수정]:</a:t>
-            </a:r>
-          </a:p>
-          <a:p>
-            <a:pPr>
-              <a:spcAft>
-                <a:spcPts val="600"/>
-              </a:spcAft>
-              <a:defRPr sz="1100">
-                <a:solidFill>
-                  <a:srgbClr val="94A3B8"/>
-                </a:solidFill>
-                <a:latin typeface="Noto Sans KR"/>
-              </a:defRPr>
-            </a:pPr>
-            <a:r>
-              <a:t>• 채점을 시작하거나 이미 제출한 내용을 재조정할 때 버튼을 선택해 작업장(Workspace)으로 진입합니다.</a:t>
+              <a:t>⚠️ 결격 사유 발생 시:</a:t>
+            </a:r>
+          </a:p>
+          <a:p>
+            <a:pPr>
+              <a:spcAft>
+                <a:spcPts val="600"/>
+              </a:spcAft>
+              <a:defRPr sz="1100">
+                <a:solidFill>
+                  <a:srgbClr val="94A3B8"/>
+                </a:solidFill>
+                <a:latin typeface="Noto Sans KR"/>
+              </a:defRPr>
+            </a:pPr>
+            <a:r>
+              <a:t>• 표절, 중요 기밀 및 API Key 노출 등이 발견되어 결격 처리된 경우, 평균 점수가 70점 이상이어도 최종 판정은 '불합격' 처리됩니다.</a:t>
             </a:r>
           </a:p>
           <a:p>
@@ -3742,7 +3775,7 @@
               </a:defRPr>
             </a:pPr>
             <a:r>
-              <a:t>오른쪽 화면: 실제 심사위원이 접하는 과제 목록 테이블 영역</a:t>
+              <a:t>오른쪽 화면: 서명이 실제 심사위원 성명으로 연동된 결과 보고서 하단부</a:t>
             </a:r>
           </a:p>
         </p:txBody>
@@ -3794,7 +3827,7 @@
       </p:sp>
       <p:pic>
         <p:nvPicPr>
-          <p:cNvPr id="10" name="Picture 9" descr="media__1784176902473.png"/>
+          <p:cNvPr id="10" name="Picture 9" descr="media__1784596287593.png"/>
           <p:cNvPicPr>
             <a:picLocks noChangeAspect="1"/>
           </p:cNvPicPr>
@@ -3808,8 +3841,8 @@
         </p:blipFill>
         <p:spPr>
           <a:xfrm>
-            <a:off x="6814049" y="1965960"/>
-            <a:ext cx="4385580" cy="3840480"/>
+            <a:off x="7059982" y="1965960"/>
+            <a:ext cx="3893714" cy="3840480"/>
           </a:xfrm>
           <a:prstGeom prst="rect">
             <a:avLst/>
@@ -3909,7 +3942,7 @@
               </a:defRPr>
             </a:pPr>
             <a:r>
-              <a:t>채점 전에 제출물의 연결성과 재현 가능성을 봅니다</a:t>
+              <a:t>내 배정 과제 큐에서 심사 우선순위를 잡습니다</a:t>
             </a:r>
           </a:p>
         </p:txBody>
@@ -4024,7 +4057,7 @@
               </a:defRPr>
             </a:pPr>
             <a:r>
-              <a:t>11</a:t>
+              <a:t>10</a:t>
             </a:r>
           </a:p>
         </p:txBody>
@@ -4108,71 +4141,55 @@
               </a:defRPr>
             </a:pPr>
             <a:r>
-              <a:t>3대 증빙 자료 다차원 교차 검증</a:t>
-            </a:r>
-          </a:p>
-          <a:p>
-            <a:pPr>
-              <a:spcAft>
-                <a:spcPts val="600"/>
-              </a:spcAft>
-              <a:defRPr sz="1100">
-                <a:solidFill>
-                  <a:srgbClr val="94A3B8"/>
-                </a:solidFill>
-                <a:latin typeface="Noto Sans KR"/>
-              </a:defRPr>
-            </a:pPr>
-            <a:r>
-              <a:t>제출물 상세 탭(Tab) 활용 방식:</a:t>
-            </a:r>
-          </a:p>
-          <a:p>
-            <a:pPr>
-              <a:spcAft>
-                <a:spcPts val="600"/>
-              </a:spcAft>
-              <a:defRPr sz="1100">
-                <a:solidFill>
-                  <a:srgbClr val="94A3B8"/>
-                </a:solidFill>
-                <a:latin typeface="Noto Sans KR"/>
-              </a:defRPr>
-            </a:pPr>
-            <a:r>
-              <a:t>• 보고서 요약 (Tab 1): 과제 제안 배경 및 Pain Point 극복 방안, 6S 요약 검토 (문제-해결-기대효과의 논리적 일관성 체크)</a:t>
-            </a:r>
-          </a:p>
-          <a:p>
-            <a:pPr>
-              <a:spcAft>
-                <a:spcPts val="600"/>
-              </a:spcAft>
-              <a:defRPr sz="1100">
-                <a:solidFill>
-                  <a:srgbClr val="94A3B8"/>
-                </a:solidFill>
-                <a:latin typeface="Noto Sans KR"/>
-              </a:defRPr>
-            </a:pPr>
-            <a:r>
-              <a:t>• 소스코드 구조 (Tab 2): 디렉토리 트리 구조, 라이브러리 구성 및 API Key 노출 방지 대책 검토</a:t>
-            </a:r>
-          </a:p>
-          <a:p>
-            <a:pPr>
-              <a:spcAft>
-                <a:spcPts val="600"/>
-              </a:spcAft>
-              <a:defRPr sz="1100">
-                <a:solidFill>
-                  <a:srgbClr val="94A3B8"/>
-                </a:solidFill>
-                <a:latin typeface="Noto Sans KR"/>
-              </a:defRPr>
-            </a:pPr>
-            <a:r>
-              <a:t>• 시연·링크 (Tab 3): 결과 보고서 PDF 원본, Git 저장소 주소, 구동 동영상 링크 유효성 검증</a:t>
+              <a:t>심사 위원 배정 큐 모니터링</a:t>
+            </a:r>
+          </a:p>
+          <a:p>
+            <a:pPr>
+              <a:spcAft>
+                <a:spcPts val="600"/>
+              </a:spcAft>
+              <a:defRPr sz="1100">
+                <a:solidFill>
+                  <a:srgbClr val="94A3B8"/>
+                </a:solidFill>
+                <a:latin typeface="Noto Sans KR"/>
+              </a:defRPr>
+            </a:pPr>
+            <a:r>
+              <a:t>심사위원 전용 배정 과제 리스트 가이드:</a:t>
+            </a:r>
+          </a:p>
+          <a:p>
+            <a:pPr>
+              <a:spcAft>
+                <a:spcPts val="600"/>
+              </a:spcAft>
+              <a:defRPr sz="1100">
+                <a:solidFill>
+                  <a:srgbClr val="94A3B8"/>
+                </a:solidFill>
+                <a:latin typeface="Noto Sans KR"/>
+              </a:defRPr>
+            </a:pPr>
+            <a:r>
+              <a:t>• 성명 및 이메일 로그인 시, 본인이 패널로 등록된 평가 과제만 화면에 정렬됩니다.</a:t>
+            </a:r>
+          </a:p>
+          <a:p>
+            <a:pPr>
+              <a:spcAft>
+                <a:spcPts val="600"/>
+              </a:spcAft>
+              <a:defRPr sz="1100">
+                <a:solidFill>
+                  <a:srgbClr val="94A3B8"/>
+                </a:solidFill>
+                <a:latin typeface="Noto Sans KR"/>
+              </a:defRPr>
+            </a:pPr>
+            <a:r>
+              <a:t>• 테이블 컬럼: 지원자 정보, 소속 법인/부서, 자격 인증 레벨, 내 평가 진행 현황(대기/완료), 타 위원 제출 진척 상태 배지 표시</a:t>
             </a:r>
           </a:p>
           <a:p>
@@ -4189,7 +4206,23 @@
               </a:defRPr>
             </a:pPr>
             <a:r>
-              <a:t>💡 소스코드 및 구동 영상 링크가 손상되었을 경우 정성 의견란에 구체적인 비작동 사유를 기재해 주세요.</a:t>
+              <a:t>[심사하기/수정]:</a:t>
+            </a:r>
+          </a:p>
+          <a:p>
+            <a:pPr>
+              <a:spcAft>
+                <a:spcPts val="600"/>
+              </a:spcAft>
+              <a:defRPr sz="1100">
+                <a:solidFill>
+                  <a:srgbClr val="94A3B8"/>
+                </a:solidFill>
+                <a:latin typeface="Noto Sans KR"/>
+              </a:defRPr>
+            </a:pPr>
+            <a:r>
+              <a:t>• 채점을 시작하거나 이미 제출한 내용을 재조정할 때 버튼을 선택해 작업장(Workspace)으로 진입합니다.</a:t>
             </a:r>
           </a:p>
           <a:p>
@@ -4206,7 +4239,7 @@
               </a:defRPr>
             </a:pPr>
             <a:r>
-              <a:t>오른쪽 화면: 실제 심사 작업장 좌측의 3단 증빙 자료 리더(Reader)</a:t>
+              <a:t>오른쪽 화면: 실제 심사위원이 접하는 과제 목록 테이블 영역</a:t>
             </a:r>
           </a:p>
         </p:txBody>
@@ -4258,7 +4291,7 @@
       </p:sp>
       <p:pic>
         <p:nvPicPr>
-          <p:cNvPr id="10" name="Picture 9" descr="aica_evaluation_workspace_mockup_1784167999282.png"/>
+          <p:cNvPr id="10" name="Picture 9" descr="media__1784176902473.png"/>
           <p:cNvPicPr>
             <a:picLocks noChangeAspect="1"/>
           </p:cNvPicPr>
@@ -4272,8 +4305,8 @@
         </p:blipFill>
         <p:spPr>
           <a:xfrm>
-            <a:off x="7086600" y="1965960"/>
-            <a:ext cx="3840480" cy="3840480"/>
+            <a:off x="6814049" y="1965960"/>
+            <a:ext cx="4385580" cy="3840480"/>
           </a:xfrm>
           <a:prstGeom prst="rect">
             <a:avLst/>
@@ -4373,7 +4406,7 @@
               </a:defRPr>
             </a:pPr>
             <a:r>
-              <a:t>공통 보안 체크리스트는 모든 심사의 선행 조건입니다</a:t>
+              <a:t>채점 전에 제출물의 연결성과 재현 가능성을 봅니다</a:t>
             </a:r>
           </a:p>
         </p:txBody>
@@ -4488,7 +4521,7 @@
               </a:defRPr>
             </a:pPr>
             <a:r>
-              <a:t>12</a:t>
+              <a:t>11</a:t>
             </a:r>
           </a:p>
         </p:txBody>
@@ -4572,103 +4605,71 @@
               </a:defRPr>
             </a:pPr>
             <a:r>
-              <a:t>5대 공통 보안성 자가진단 규칙</a:t>
-            </a:r>
-          </a:p>
-          <a:p>
-            <a:pPr>
-              <a:spcAft>
-                <a:spcPts val="600"/>
-              </a:spcAft>
-              <a:defRPr sz="1100">
-                <a:solidFill>
-                  <a:srgbClr val="94A3B8"/>
-                </a:solidFill>
-                <a:latin typeface="Noto Sans KR"/>
-              </a:defRPr>
-            </a:pPr>
-            <a:r>
-              <a:t>모든 심사의 최우선 선행 체크리스트:</a:t>
-            </a:r>
-          </a:p>
-          <a:p>
-            <a:pPr>
-              <a:spcAft>
-                <a:spcPts val="600"/>
-              </a:spcAft>
-              <a:defRPr sz="1100">
-                <a:solidFill>
-                  <a:srgbClr val="94A3B8"/>
-                </a:solidFill>
-                <a:latin typeface="Noto Sans KR"/>
-              </a:defRPr>
-            </a:pPr>
-            <a:r>
-              <a:t>• 1. 개인정보(PII): 이름, 메일주소, 연락처 등 완벽 마스킹 여부</a:t>
-            </a:r>
-          </a:p>
-          <a:p>
-            <a:pPr>
-              <a:spcAft>
-                <a:spcPts val="600"/>
-              </a:spcAft>
-              <a:defRPr sz="1100">
-                <a:solidFill>
-                  <a:srgbClr val="94A3B8"/>
-                </a:solidFill>
-                <a:latin typeface="Noto Sans KR"/>
-              </a:defRPr>
-            </a:pPr>
-            <a:r>
-              <a:t>• 2. 기밀 정보 익명화: 계약 금액, 단가, 마진율 등 기밀 제거 여부</a:t>
-            </a:r>
-          </a:p>
-          <a:p>
-            <a:pPr>
-              <a:spcAft>
-                <a:spcPts val="600"/>
-              </a:spcAft>
-              <a:defRPr sz="1100">
-                <a:solidFill>
-                  <a:srgbClr val="94A3B8"/>
-                </a:solidFill>
-                <a:latin typeface="Noto Sans KR"/>
-              </a:defRPr>
-            </a:pPr>
-            <a:r>
-              <a:t>• 3. 자격증명 제거: 소스코드 내 API Key, ID/PW 제거 여부</a:t>
-            </a:r>
-          </a:p>
-          <a:p>
-            <a:pPr>
-              <a:spcAft>
-                <a:spcPts val="600"/>
-              </a:spcAft>
-              <a:defRPr sz="1100">
-                <a:solidFill>
-                  <a:srgbClr val="94A3B8"/>
-                </a:solidFill>
-                <a:latin typeface="Noto Sans KR"/>
-              </a:defRPr>
-            </a:pPr>
-            <a:r>
-              <a:t>• 4. 보안 가이드 준수: 보안실 배포 규정 및 자가점검 여부</a:t>
-            </a:r>
-          </a:p>
-          <a:p>
-            <a:pPr>
-              <a:spcAft>
-                <a:spcPts val="600"/>
-              </a:spcAft>
-              <a:defRPr sz="1100">
-                <a:solidFill>
-                  <a:srgbClr val="94A3B8"/>
-                </a:solidFill>
-                <a:latin typeface="Noto Sans KR"/>
-              </a:defRPr>
-            </a:pPr>
-            <a:r>
-              <a:t>• 5. 유출 위반 차단: 타 부서 및 망 분리 활용 시 유출 위험 제거 여부</a:t>
+              <a:t>3대 증빙 자료 다차원 교차 검증</a:t>
+            </a:r>
+          </a:p>
+          <a:p>
+            <a:pPr>
+              <a:spcAft>
+                <a:spcPts val="600"/>
+              </a:spcAft>
+              <a:defRPr sz="1100">
+                <a:solidFill>
+                  <a:srgbClr val="94A3B8"/>
+                </a:solidFill>
+                <a:latin typeface="Noto Sans KR"/>
+              </a:defRPr>
+            </a:pPr>
+            <a:r>
+              <a:t>제출물 상세 탭(Tab) 활용 방식:</a:t>
+            </a:r>
+          </a:p>
+          <a:p>
+            <a:pPr>
+              <a:spcAft>
+                <a:spcPts val="600"/>
+              </a:spcAft>
+              <a:defRPr sz="1100">
+                <a:solidFill>
+                  <a:srgbClr val="94A3B8"/>
+                </a:solidFill>
+                <a:latin typeface="Noto Sans KR"/>
+              </a:defRPr>
+            </a:pPr>
+            <a:r>
+              <a:t>• 보고서 요약 (Tab 1): 과제 제안 배경 및 Pain Point 극복 방안, 6S 요약 검토 (문제-해결-기대효과의 논리적 일관성 체크)</a:t>
+            </a:r>
+          </a:p>
+          <a:p>
+            <a:pPr>
+              <a:spcAft>
+                <a:spcPts val="600"/>
+              </a:spcAft>
+              <a:defRPr sz="1100">
+                <a:solidFill>
+                  <a:srgbClr val="94A3B8"/>
+                </a:solidFill>
+                <a:latin typeface="Noto Sans KR"/>
+              </a:defRPr>
+            </a:pPr>
+            <a:r>
+              <a:t>• 소스코드 구조 (Tab 2): 디렉토리 트리 구조, 라이브러리 구성 및 API Key 노출 방지 대책 검토</a:t>
+            </a:r>
+          </a:p>
+          <a:p>
+            <a:pPr>
+              <a:spcAft>
+                <a:spcPts val="600"/>
+              </a:spcAft>
+              <a:defRPr sz="1100">
+                <a:solidFill>
+                  <a:srgbClr val="94A3B8"/>
+                </a:solidFill>
+                <a:latin typeface="Noto Sans KR"/>
+              </a:defRPr>
+            </a:pPr>
+            <a:r>
+              <a:t>• 시연·링크 (Tab 3): 결과 보고서 PDF 원본, Git 저장소 주소, 구동 동영상 링크 유효성 검증</a:t>
             </a:r>
           </a:p>
           <a:p>
@@ -4685,23 +4686,7 @@
               </a:defRPr>
             </a:pPr>
             <a:r>
-              <a:t>⚠️ Red Flag 경고 연동:</a:t>
-            </a:r>
-          </a:p>
-          <a:p>
-            <a:pPr>
-              <a:spcAft>
-                <a:spcPts val="600"/>
-              </a:spcAft>
-              <a:defRPr sz="1100">
-                <a:solidFill>
-                  <a:srgbClr val="94A3B8"/>
-                </a:solidFill>
-                <a:latin typeface="Noto Sans KR"/>
-              </a:defRPr>
-            </a:pPr>
-            <a:r>
-              <a:t>• 하나라도 미준수 시 '보안 주의 알림'이 대시보드에 연동되며, 중대한 자격증명 노출은 즉시 불합격 처리 대상이 됩니다.</a:t>
+              <a:t>💡 소스코드 및 구동 영상 링크가 손상되었을 경우 정성 의견란에 구체적인 비작동 사유를 기재해 주세요.</a:t>
             </a:r>
           </a:p>
           <a:p>
@@ -4718,7 +4703,7 @@
               </a:defRPr>
             </a:pPr>
             <a:r>
-              <a:t>오른쪽 화면: 실제 채점 페이지 좌측 하단 보안 체크리스트 영역</a:t>
+              <a:t>오른쪽 화면: 실제 심사 작업장 좌측의 3단 증빙 자료 리더(Reader)</a:t>
             </a:r>
           </a:p>
         </p:txBody>
@@ -4770,7 +4755,7 @@
       </p:sp>
       <p:pic>
         <p:nvPicPr>
-          <p:cNvPr id="10" name="Picture 9" descr="media__1784176902473.png"/>
+          <p:cNvPr id="10" name="Picture 9" descr="aica_evaluation_workspace_mockup_1784167999282.png"/>
           <p:cNvPicPr>
             <a:picLocks noChangeAspect="1"/>
           </p:cNvPicPr>
@@ -4784,8 +4769,8 @@
         </p:blipFill>
         <p:spPr>
           <a:xfrm>
-            <a:off x="6814049" y="1965960"/>
-            <a:ext cx="4385580" cy="3840480"/>
+            <a:off x="7086600" y="1965960"/>
+            <a:ext cx="3840480" cy="3840480"/>
           </a:xfrm>
           <a:prstGeom prst="rect">
             <a:avLst/>
@@ -4885,7 +4870,7 @@
               </a:defRPr>
             </a:pPr>
             <a:r>
-              <a:t>Level에 따라 채점 축과 가중치가 달라집니다</a:t>
+              <a:t>공통 보안 체크리스트는 모든 심사의 선행 조건입니다</a:t>
             </a:r>
           </a:p>
         </p:txBody>
@@ -5000,7 +4985,7 @@
               </a:defRPr>
             </a:pPr>
             <a:r>
-              <a:t>13</a:t>
+              <a:t>12</a:t>
             </a:r>
           </a:p>
         </p:txBody>
@@ -5084,151 +5069,103 @@
               </a:defRPr>
             </a:pPr>
             <a:r>
-              <a:t>심사 자격 레벨별 가중치 및 배점 척도</a:t>
-            </a:r>
-          </a:p>
-          <a:p>
-            <a:pPr>
-              <a:spcAft>
-                <a:spcPts val="600"/>
-              </a:spcAft>
-              <a:defRPr sz="1100">
-                <a:solidFill>
-                  <a:srgbClr val="94A3B8"/>
-                </a:solidFill>
-                <a:latin typeface="Noto Sans KR"/>
-              </a:defRPr>
-            </a:pPr>
-            <a:r>
-              <a:t>자격 등급별 평가 주안점 및 비율:</a:t>
-            </a:r>
-          </a:p>
-          <a:p>
-            <a:pPr>
-              <a:spcAft>
-                <a:spcPts val="600"/>
-              </a:spcAft>
-              <a:defRPr sz="1100">
-                <a:solidFill>
-                  <a:srgbClr val="94A3B8"/>
-                </a:solidFill>
-                <a:latin typeface="Noto Sans KR"/>
-              </a:defRPr>
-            </a:pPr>
-            <a:r>
-              <a:t>• Level 3 (AI Champion): 현업 적용성 및 기여 효과 검증</a:t>
-            </a:r>
-          </a:p>
-          <a:p>
-            <a:pPr>
-              <a:spcAft>
-                <a:spcPts val="600"/>
-              </a:spcAft>
-              <a:defRPr sz="1100">
-                <a:solidFill>
-                  <a:srgbClr val="94A3B8"/>
-                </a:solidFill>
-                <a:latin typeface="Noto Sans KR"/>
-              </a:defRPr>
-            </a:pPr>
-            <a:r>
-              <a:t>   - 문제 해결 난이도 (30%)</a:t>
-            </a:r>
-          </a:p>
-          <a:p>
-            <a:pPr>
-              <a:spcAft>
-                <a:spcPts val="600"/>
-              </a:spcAft>
-              <a:defRPr sz="1100">
-                <a:solidFill>
-                  <a:srgbClr val="94A3B8"/>
-                </a:solidFill>
-                <a:latin typeface="Noto Sans KR"/>
-              </a:defRPr>
-            </a:pPr>
-            <a:r>
-              <a:t>   - 구현 완성도 (40%)</a:t>
-            </a:r>
-          </a:p>
-          <a:p>
-            <a:pPr>
-              <a:spcAft>
-                <a:spcPts val="600"/>
-              </a:spcAft>
-              <a:defRPr sz="1100">
-                <a:solidFill>
-                  <a:srgbClr val="94A3B8"/>
-                </a:solidFill>
-                <a:latin typeface="Noto Sans KR"/>
-              </a:defRPr>
-            </a:pPr>
-            <a:r>
-              <a:t>   - 확산 및 자산화 (30%)</a:t>
-            </a:r>
-          </a:p>
-          <a:p>
-            <a:pPr>
-              <a:spcAft>
-                <a:spcPts val="600"/>
-              </a:spcAft>
-              <a:defRPr sz="1100">
-                <a:solidFill>
-                  <a:srgbClr val="94A3B8"/>
-                </a:solidFill>
-                <a:latin typeface="Noto Sans KR"/>
-              </a:defRPr>
-            </a:pPr>
-            <a:r>
-              <a:t>• Level 4 (AI Specialist): 심화 기술력 및 보안 통제 깊이 검증</a:t>
-            </a:r>
-          </a:p>
-          <a:p>
-            <a:pPr>
-              <a:spcAft>
-                <a:spcPts val="600"/>
-              </a:spcAft>
-              <a:defRPr sz="1100">
-                <a:solidFill>
-                  <a:srgbClr val="94A3B8"/>
-                </a:solidFill>
-                <a:latin typeface="Noto Sans KR"/>
-              </a:defRPr>
-            </a:pPr>
-            <a:r>
-              <a:t>   - 기술적 구현력 (40%)</a:t>
-            </a:r>
-          </a:p>
-          <a:p>
-            <a:pPr>
-              <a:spcAft>
-                <a:spcPts val="600"/>
-              </a:spcAft>
-              <a:defRPr sz="1100">
-                <a:solidFill>
-                  <a:srgbClr val="94A3B8"/>
-                </a:solidFill>
-                <a:latin typeface="Noto Sans KR"/>
-              </a:defRPr>
-            </a:pPr>
-            <a:r>
-              <a:t>   - 데이터 활용 및 보안성 (30%)</a:t>
-            </a:r>
-          </a:p>
-          <a:p>
-            <a:pPr>
-              <a:spcAft>
-                <a:spcPts val="600"/>
-              </a:spcAft>
-              <a:defRPr sz="1100">
-                <a:solidFill>
-                  <a:srgbClr val="94A3B8"/>
-                </a:solidFill>
-                <a:latin typeface="Noto Sans KR"/>
-              </a:defRPr>
-            </a:pPr>
-            <a:r>
-              <a:t>   - 비즈니스 기여도 (30%)</a:t>
+              <a:t>5대 공통 보안성 자가진단 규칙</a:t>
+            </a:r>
+          </a:p>
+          <a:p>
+            <a:pPr>
+              <a:spcAft>
+                <a:spcPts val="600"/>
+              </a:spcAft>
+              <a:defRPr sz="1100">
+                <a:solidFill>
+                  <a:srgbClr val="94A3B8"/>
+                </a:solidFill>
+                <a:latin typeface="Noto Sans KR"/>
+              </a:defRPr>
+            </a:pPr>
+            <a:r>
+              <a:t>모든 심사의 최우선 선행 체크리스트:</a:t>
+            </a:r>
+          </a:p>
+          <a:p>
+            <a:pPr>
+              <a:spcAft>
+                <a:spcPts val="600"/>
+              </a:spcAft>
+              <a:defRPr sz="1100">
+                <a:solidFill>
+                  <a:srgbClr val="94A3B8"/>
+                </a:solidFill>
+                <a:latin typeface="Noto Sans KR"/>
+              </a:defRPr>
+            </a:pPr>
+            <a:r>
+              <a:t>• 1. 개인정보(PII): 이름, 메일주소, 연락처 등 완벽 마스킹 여부</a:t>
+            </a:r>
+          </a:p>
+          <a:p>
+            <a:pPr>
+              <a:spcAft>
+                <a:spcPts val="600"/>
+              </a:spcAft>
+              <a:defRPr sz="1100">
+                <a:solidFill>
+                  <a:srgbClr val="94A3B8"/>
+                </a:solidFill>
+                <a:latin typeface="Noto Sans KR"/>
+              </a:defRPr>
+            </a:pPr>
+            <a:r>
+              <a:t>• 2. 기밀 정보 익명화: 계약 금액, 단가, 마진율 등 기밀 제거 여부</a:t>
+            </a:r>
+          </a:p>
+          <a:p>
+            <a:pPr>
+              <a:spcAft>
+                <a:spcPts val="600"/>
+              </a:spcAft>
+              <a:defRPr sz="1100">
+                <a:solidFill>
+                  <a:srgbClr val="94A3B8"/>
+                </a:solidFill>
+                <a:latin typeface="Noto Sans KR"/>
+              </a:defRPr>
+            </a:pPr>
+            <a:r>
+              <a:t>• 3. 자격증명 제거: 소스코드 내 API Key, ID/PW 제거 여부</a:t>
+            </a:r>
+          </a:p>
+          <a:p>
+            <a:pPr>
+              <a:spcAft>
+                <a:spcPts val="600"/>
+              </a:spcAft>
+              <a:defRPr sz="1100">
+                <a:solidFill>
+                  <a:srgbClr val="94A3B8"/>
+                </a:solidFill>
+                <a:latin typeface="Noto Sans KR"/>
+              </a:defRPr>
+            </a:pPr>
+            <a:r>
+              <a:t>• 4. 보안 가이드 준수: 보안실 배포 규정 및 자가점검 여부</a:t>
+            </a:r>
+          </a:p>
+          <a:p>
+            <a:pPr>
+              <a:spcAft>
+                <a:spcPts val="600"/>
+              </a:spcAft>
+              <a:defRPr sz="1100">
+                <a:solidFill>
+                  <a:srgbClr val="94A3B8"/>
+                </a:solidFill>
+                <a:latin typeface="Noto Sans KR"/>
+              </a:defRPr>
+            </a:pPr>
+            <a:r>
+              <a:t>• 5. 유출 위반 차단: 타 부서 및 망 분리 활용 시 유출 위험 제거 여부</a:t>
             </a:r>
           </a:p>
           <a:p>
@@ -5245,7 +5182,40 @@
               </a:defRPr>
             </a:pPr>
             <a:r>
-              <a:t>오른쪽 화면: 실제 채점 페이지 우측의 루브릭 점수 선택 라디오 영역</a:t>
+              <a:t>⚠️ Red Flag 경고 연동:</a:t>
+            </a:r>
+          </a:p>
+          <a:p>
+            <a:pPr>
+              <a:spcAft>
+                <a:spcPts val="600"/>
+              </a:spcAft>
+              <a:defRPr sz="1100">
+                <a:solidFill>
+                  <a:srgbClr val="94A3B8"/>
+                </a:solidFill>
+                <a:latin typeface="Noto Sans KR"/>
+              </a:defRPr>
+            </a:pPr>
+            <a:r>
+              <a:t>• 하나라도 미준수 시 '보안 주의 알림'이 대시보드에 연동되며, 중대한 자격증명 노출은 즉시 불합격 처리 대상이 됩니다.</a:t>
+            </a:r>
+          </a:p>
+          <a:p>
+            <a:br/>
+            <a:pPr>
+              <a:spcAft>
+                <a:spcPts val="600"/>
+              </a:spcAft>
+              <a:defRPr sz="1100">
+                <a:solidFill>
+                  <a:srgbClr val="94A3B8"/>
+                </a:solidFill>
+                <a:latin typeface="Noto Sans KR"/>
+              </a:defRPr>
+            </a:pPr>
+            <a:r>
+              <a:t>오른쪽 화면: 실제 채점 페이지 좌측 하단 보안 체크리스트 영역</a:t>
             </a:r>
           </a:p>
         </p:txBody>
@@ -5412,7 +5382,7 @@
               </a:defRPr>
             </a:pPr>
             <a:r>
-              <a:t>점수와 의견은 반드시 같은 근거를 가리켜야 합니다</a:t>
+              <a:t>Level에 따라 채점 축과 가중치가 달라집니다</a:t>
             </a:r>
           </a:p>
         </p:txBody>
@@ -5527,7 +5497,7 @@
               </a:defRPr>
             </a:pPr>
             <a:r>
-              <a:t>14</a:t>
+              <a:t>13</a:t>
             </a:r>
           </a:p>
         </p:txBody>
@@ -5611,55 +5581,151 @@
               </a:defRPr>
             </a:pPr>
             <a:r>
-              <a:t>세부 루브릭 채점 및 질문은행 면접 툴</a:t>
-            </a:r>
-          </a:p>
-          <a:p>
-            <a:pPr>
-              <a:spcAft>
-                <a:spcPts val="600"/>
-              </a:spcAft>
-              <a:defRPr sz="1100">
-                <a:solidFill>
-                  <a:srgbClr val="94A3B8"/>
-                </a:solidFill>
-                <a:latin typeface="Noto Sans KR"/>
-              </a:defRPr>
-            </a:pPr>
-            <a:r>
-              <a:t>루브릭 세부 채점 가이드:</a:t>
-            </a:r>
-          </a:p>
-          <a:p>
-            <a:pPr>
-              <a:spcAft>
-                <a:spcPts val="600"/>
-              </a:spcAft>
-              <a:defRPr sz="1100">
-                <a:solidFill>
-                  <a:srgbClr val="94A3B8"/>
-                </a:solidFill>
-                <a:latin typeface="Noto Sans KR"/>
-              </a:defRPr>
-            </a:pPr>
-            <a:r>
-              <a:t>• 5단계 등급 선택: (탁월 100, 양호 85, 보통 70, 미흡 50, 부족 30)</a:t>
-            </a:r>
-          </a:p>
-          <a:p>
-            <a:pPr>
-              <a:spcAft>
-                <a:spcPts val="600"/>
-              </a:spcAft>
-              <a:defRPr sz="1100">
-                <a:solidFill>
-                  <a:srgbClr val="94A3B8"/>
-                </a:solidFill>
-                <a:latin typeface="Noto Sans KR"/>
-              </a:defRPr>
-            </a:pPr>
-            <a:r>
-              <a:t>• 각 항목마다 정량적/정성적 등급 부여 사유 필수 기재</a:t>
+              <a:t>심사 자격 레벨별 가중치 및 배점 척도</a:t>
+            </a:r>
+          </a:p>
+          <a:p>
+            <a:pPr>
+              <a:spcAft>
+                <a:spcPts val="600"/>
+              </a:spcAft>
+              <a:defRPr sz="1100">
+                <a:solidFill>
+                  <a:srgbClr val="94A3B8"/>
+                </a:solidFill>
+                <a:latin typeface="Noto Sans KR"/>
+              </a:defRPr>
+            </a:pPr>
+            <a:r>
+              <a:t>자격 등급별 평가 주안점 및 비율:</a:t>
+            </a:r>
+          </a:p>
+          <a:p>
+            <a:pPr>
+              <a:spcAft>
+                <a:spcPts val="600"/>
+              </a:spcAft>
+              <a:defRPr sz="1100">
+                <a:solidFill>
+                  <a:srgbClr val="94A3B8"/>
+                </a:solidFill>
+                <a:latin typeface="Noto Sans KR"/>
+              </a:defRPr>
+            </a:pPr>
+            <a:r>
+              <a:t>• Level 3 (AI Champion): 현업 적용성 및 기여 효과 검증</a:t>
+            </a:r>
+          </a:p>
+          <a:p>
+            <a:pPr>
+              <a:spcAft>
+                <a:spcPts val="600"/>
+              </a:spcAft>
+              <a:defRPr sz="1100">
+                <a:solidFill>
+                  <a:srgbClr val="94A3B8"/>
+                </a:solidFill>
+                <a:latin typeface="Noto Sans KR"/>
+              </a:defRPr>
+            </a:pPr>
+            <a:r>
+              <a:t>   - 문제 해결 난이도 (30%)</a:t>
+            </a:r>
+          </a:p>
+          <a:p>
+            <a:pPr>
+              <a:spcAft>
+                <a:spcPts val="600"/>
+              </a:spcAft>
+              <a:defRPr sz="1100">
+                <a:solidFill>
+                  <a:srgbClr val="94A3B8"/>
+                </a:solidFill>
+                <a:latin typeface="Noto Sans KR"/>
+              </a:defRPr>
+            </a:pPr>
+            <a:r>
+              <a:t>   - 구현 완성도 (40%)</a:t>
+            </a:r>
+          </a:p>
+          <a:p>
+            <a:pPr>
+              <a:spcAft>
+                <a:spcPts val="600"/>
+              </a:spcAft>
+              <a:defRPr sz="1100">
+                <a:solidFill>
+                  <a:srgbClr val="94A3B8"/>
+                </a:solidFill>
+                <a:latin typeface="Noto Sans KR"/>
+              </a:defRPr>
+            </a:pPr>
+            <a:r>
+              <a:t>   - 확산 및 자산화 (30%)</a:t>
+            </a:r>
+          </a:p>
+          <a:p>
+            <a:pPr>
+              <a:spcAft>
+                <a:spcPts val="600"/>
+              </a:spcAft>
+              <a:defRPr sz="1100">
+                <a:solidFill>
+                  <a:srgbClr val="94A3B8"/>
+                </a:solidFill>
+                <a:latin typeface="Noto Sans KR"/>
+              </a:defRPr>
+            </a:pPr>
+            <a:r>
+              <a:t>• Level 4 (AI Specialist): 심화 기술력 및 보안 통제 깊이 검증</a:t>
+            </a:r>
+          </a:p>
+          <a:p>
+            <a:pPr>
+              <a:spcAft>
+                <a:spcPts val="600"/>
+              </a:spcAft>
+              <a:defRPr sz="1100">
+                <a:solidFill>
+                  <a:srgbClr val="94A3B8"/>
+                </a:solidFill>
+                <a:latin typeface="Noto Sans KR"/>
+              </a:defRPr>
+            </a:pPr>
+            <a:r>
+              <a:t>   - 기술적 구현력 (40%)</a:t>
+            </a:r>
+          </a:p>
+          <a:p>
+            <a:pPr>
+              <a:spcAft>
+                <a:spcPts val="600"/>
+              </a:spcAft>
+              <a:defRPr sz="1100">
+                <a:solidFill>
+                  <a:srgbClr val="94A3B8"/>
+                </a:solidFill>
+                <a:latin typeface="Noto Sans KR"/>
+              </a:defRPr>
+            </a:pPr>
+            <a:r>
+              <a:t>   - 데이터 활용 및 보안성 (30%)</a:t>
+            </a:r>
+          </a:p>
+          <a:p>
+            <a:pPr>
+              <a:spcAft>
+                <a:spcPts val="600"/>
+              </a:spcAft>
+              <a:defRPr sz="1100">
+                <a:solidFill>
+                  <a:srgbClr val="94A3B8"/>
+                </a:solidFill>
+                <a:latin typeface="Noto Sans KR"/>
+              </a:defRPr>
+            </a:pPr>
+            <a:r>
+              <a:t>   - 비즈니스 기여도 (30%)</a:t>
             </a:r>
           </a:p>
           <a:p>
@@ -5676,73 +5742,7 @@
               </a:defRPr>
             </a:pPr>
             <a:r>
-              <a:t>⚡ Consensus Monitor (의견 불합치 방지):</a:t>
-            </a:r>
-          </a:p>
-          <a:p>
-            <a:pPr>
-              <a:spcAft>
-                <a:spcPts val="600"/>
-              </a:spcAft>
-              <a:defRPr sz="1100">
-                <a:solidFill>
-                  <a:srgbClr val="94A3B8"/>
-                </a:solidFill>
-                <a:latin typeface="Noto Sans KR"/>
-              </a:defRPr>
-            </a:pPr>
-            <a:r>
-              <a:t>• 동시 배정된 위원 간 평가 편차가 15점 이상 벌어질 경우 경고 알림 노출 ➡️ 타 위원 의견 수렴 후 조율 합의문 기재</a:t>
-            </a:r>
-          </a:p>
-          <a:p>
-            <a:br/>
-            <a:pPr>
-              <a:spcAft>
-                <a:spcPts val="600"/>
-              </a:spcAft>
-              <a:defRPr sz="1100">
-                <a:solidFill>
-                  <a:srgbClr val="94A3B8"/>
-                </a:solidFill>
-                <a:latin typeface="Noto Sans KR"/>
-              </a:defRPr>
-            </a:pPr>
-            <a:r>
-              <a:t>질문은행 도우미 (Question Bank):</a:t>
-            </a:r>
-          </a:p>
-          <a:p>
-            <a:pPr>
-              <a:spcAft>
-                <a:spcPts val="600"/>
-              </a:spcAft>
-              <a:defRPr sz="1100">
-                <a:solidFill>
-                  <a:srgbClr val="94A3B8"/>
-                </a:solidFill>
-                <a:latin typeface="Noto Sans KR"/>
-              </a:defRPr>
-            </a:pPr>
-            <a:r>
-              <a:t>• 지원자 과제 유형을 선택하면 면접 질문 리스트와 모범 답변 준거 가이드를 자동으로 제시하여 객관성을 보장합니다.</a:t>
-            </a:r>
-          </a:p>
-          <a:p>
-            <a:br/>
-            <a:pPr>
-              <a:spcAft>
-                <a:spcPts val="600"/>
-              </a:spcAft>
-              <a:defRPr sz="1100">
-                <a:solidFill>
-                  <a:srgbClr val="94A3B8"/>
-                </a:solidFill>
-                <a:latin typeface="Noto Sans KR"/>
-              </a:defRPr>
-            </a:pPr>
-            <a:r>
-              <a:t>오른쪽 화면: 실제 5단계 루브릭 행 카드 및 우측 하단 질문은행 패널 렌더링 화면</a:t>
+              <a:t>오른쪽 화면: 실제 채점 페이지 우측의 루브릭 점수 선택 라디오 영역</a:t>
             </a:r>
           </a:p>
         </p:txBody>
@@ -5794,7 +5794,7 @@
       </p:sp>
       <p:pic>
         <p:nvPicPr>
-          <p:cNvPr id="10" name="Picture 9" descr="aica_evaluation_workspace_mockup_1784167999282.png"/>
+          <p:cNvPr id="10" name="Picture 9" descr="media__1784176902473.png"/>
           <p:cNvPicPr>
             <a:picLocks noChangeAspect="1"/>
           </p:cNvPicPr>
@@ -5808,8 +5808,8 @@
         </p:blipFill>
         <p:spPr>
           <a:xfrm>
-            <a:off x="7086600" y="1965960"/>
-            <a:ext cx="3840480" cy="3840480"/>
+            <a:off x="6814049" y="1965960"/>
+            <a:ext cx="4385580" cy="3840480"/>
           </a:xfrm>
           <a:prstGeom prst="rect">
             <a:avLst/>
@@ -5909,7 +5909,7 @@
               </a:defRPr>
             </a:pPr>
             <a:r>
-              <a:t>제출 전 마지막 확인이 평가 품질을 좌우합니다</a:t>
+              <a:t>점수와 의견은 반드시 같은 근거를 가리켜야 합니다</a:t>
             </a:r>
           </a:p>
         </p:txBody>
@@ -6024,7 +6024,7 @@
               </a:defRPr>
             </a:pPr>
             <a:r>
-              <a:t>15</a:t>
+              <a:t>14</a:t>
             </a:r>
           </a:p>
         </p:txBody>
@@ -6108,87 +6108,55 @@
               </a:defRPr>
             </a:pPr>
             <a:r>
-              <a:t>평가 최종 검토 및 제출 확정</a:t>
-            </a:r>
-          </a:p>
-          <a:p>
-            <a:pPr>
-              <a:spcAft>
-                <a:spcPts val="600"/>
-              </a:spcAft>
-              <a:defRPr sz="1100">
-                <a:solidFill>
-                  <a:srgbClr val="94A3B8"/>
-                </a:solidFill>
-                <a:latin typeface="Noto Sans KR"/>
-              </a:defRPr>
-            </a:pPr>
-            <a:r>
-              <a:t>평가 완료 및 전송 단계:</a:t>
-            </a:r>
-          </a:p>
-          <a:p>
-            <a:pPr>
-              <a:spcAft>
-                <a:spcPts val="600"/>
-              </a:spcAft>
-              <a:defRPr sz="1100">
-                <a:solidFill>
-                  <a:srgbClr val="94A3B8"/>
-                </a:solidFill>
-                <a:latin typeface="Noto Sans KR"/>
-              </a:defRPr>
-            </a:pPr>
-            <a:r>
-              <a:t>• 1. 필수값 체크: 보안 체크박스 준수, 루브릭 점수 선택, 세부 의견 누락 여부 최종 갱신</a:t>
-            </a:r>
-          </a:p>
-          <a:p>
-            <a:pPr>
-              <a:spcAft>
-                <a:spcPts val="600"/>
-              </a:spcAft>
-              <a:defRPr sz="1100">
-                <a:solidFill>
-                  <a:srgbClr val="94A3B8"/>
-                </a:solidFill>
-                <a:latin typeface="Noto Sans KR"/>
-              </a:defRPr>
-            </a:pPr>
-            <a:r>
-              <a:t>• 2. 타 위원 상태 검토: 타 위원의 점수 노출 없이 평가 진행률만 확인(독립적 판단 견지)</a:t>
-            </a:r>
-          </a:p>
-          <a:p>
-            <a:pPr>
-              <a:spcAft>
-                <a:spcPts val="600"/>
-              </a:spcAft>
-              <a:defRPr sz="1100">
-                <a:solidFill>
-                  <a:srgbClr val="94A3B8"/>
-                </a:solidFill>
-                <a:latin typeface="Noto Sans KR"/>
-              </a:defRPr>
-            </a:pPr>
-            <a:r>
-              <a:t>• 3. 평가 제출: [평가 완료 및 제출] 버튼을 선택해 데이터베이스 기록 완료</a:t>
-            </a:r>
-          </a:p>
-          <a:p>
-            <a:pPr>
-              <a:spcAft>
-                <a:spcPts val="600"/>
-              </a:spcAft>
-              <a:defRPr sz="1100">
-                <a:solidFill>
-                  <a:srgbClr val="94A3B8"/>
-                </a:solidFill>
-                <a:latin typeface="Noto Sans KR"/>
-              </a:defRPr>
-            </a:pPr>
-            <a:r>
-              <a:t>• 4. 상태 갱신 검증: 본인 대기 큐로 복귀 후 해당 과제 상태가 '완료'인지 확인</a:t>
+              <a:t>세부 루브릭 채점 및 질문은행 면접 툴</a:t>
+            </a:r>
+          </a:p>
+          <a:p>
+            <a:pPr>
+              <a:spcAft>
+                <a:spcPts val="600"/>
+              </a:spcAft>
+              <a:defRPr sz="1100">
+                <a:solidFill>
+                  <a:srgbClr val="94A3B8"/>
+                </a:solidFill>
+                <a:latin typeface="Noto Sans KR"/>
+              </a:defRPr>
+            </a:pPr>
+            <a:r>
+              <a:t>루브릭 세부 채점 가이드:</a:t>
+            </a:r>
+          </a:p>
+          <a:p>
+            <a:pPr>
+              <a:spcAft>
+                <a:spcPts val="600"/>
+              </a:spcAft>
+              <a:defRPr sz="1100">
+                <a:solidFill>
+                  <a:srgbClr val="94A3B8"/>
+                </a:solidFill>
+                <a:latin typeface="Noto Sans KR"/>
+              </a:defRPr>
+            </a:pPr>
+            <a:r>
+              <a:t>• 5단계 등급 선택: (탁월 100, 양호 85, 보통 70, 미흡 50, 부족 30)</a:t>
+            </a:r>
+          </a:p>
+          <a:p>
+            <a:pPr>
+              <a:spcAft>
+                <a:spcPts val="600"/>
+              </a:spcAft>
+              <a:defRPr sz="1100">
+                <a:solidFill>
+                  <a:srgbClr val="94A3B8"/>
+                </a:solidFill>
+                <a:latin typeface="Noto Sans KR"/>
+              </a:defRPr>
+            </a:pPr>
+            <a:r>
+              <a:t>• 각 항목마다 정량적/정성적 등급 부여 사유 필수 기재</a:t>
             </a:r>
           </a:p>
           <a:p>
@@ -6205,7 +6173,23 @@
               </a:defRPr>
             </a:pPr>
             <a:r>
-              <a:t>💡 최종 판정 계산: 3인의 패널 심사위원이 최종 제출을 모두 완료하는 즉시 파이어스토어에서 평균 점수와 판정을 계산합니다.</a:t>
+              <a:t>⚡ Consensus Monitor (의견 불합치 방지):</a:t>
+            </a:r>
+          </a:p>
+          <a:p>
+            <a:pPr>
+              <a:spcAft>
+                <a:spcPts val="600"/>
+              </a:spcAft>
+              <a:defRPr sz="1100">
+                <a:solidFill>
+                  <a:srgbClr val="94A3B8"/>
+                </a:solidFill>
+                <a:latin typeface="Noto Sans KR"/>
+              </a:defRPr>
+            </a:pPr>
+            <a:r>
+              <a:t>• 동시 배정된 위원 간 평가 편차가 15점 이상 벌어질 경우 경고 알림 노출 ➡️ 타 위원 의견 수렴 후 조율 합의문 기재</a:t>
             </a:r>
           </a:p>
           <a:p>
@@ -6222,7 +6206,40 @@
               </a:defRPr>
             </a:pPr>
             <a:r>
-              <a:t>오른쪽 화면: 실제 채점 입력창 하단의 저장 및 최종 제출 영역</a:t>
+              <a:t>질문은행 도우미 (Question Bank):</a:t>
+            </a:r>
+          </a:p>
+          <a:p>
+            <a:pPr>
+              <a:spcAft>
+                <a:spcPts val="600"/>
+              </a:spcAft>
+              <a:defRPr sz="1100">
+                <a:solidFill>
+                  <a:srgbClr val="94A3B8"/>
+                </a:solidFill>
+                <a:latin typeface="Noto Sans KR"/>
+              </a:defRPr>
+            </a:pPr>
+            <a:r>
+              <a:t>• 지원자 과제 유형을 선택하면 면접 질문 리스트와 모범 답변 준거 가이드를 자동으로 제시하여 객관성을 보장합니다.</a:t>
+            </a:r>
+          </a:p>
+          <a:p>
+            <a:br/>
+            <a:pPr>
+              <a:spcAft>
+                <a:spcPts val="600"/>
+              </a:spcAft>
+              <a:defRPr sz="1100">
+                <a:solidFill>
+                  <a:srgbClr val="94A3B8"/>
+                </a:solidFill>
+                <a:latin typeface="Noto Sans KR"/>
+              </a:defRPr>
+            </a:pPr>
+            <a:r>
+              <a:t>오른쪽 화면: 실제 5단계 루브릭 행 카드 및 우측 하단 질문은행 패널 렌더링 화면</a:t>
             </a:r>
           </a:p>
         </p:txBody>
@@ -6274,7 +6291,7 @@
       </p:sp>
       <p:pic>
         <p:nvPicPr>
-          <p:cNvPr id="10" name="Picture 9" descr="media__1784176902473.png"/>
+          <p:cNvPr id="10" name="Picture 9" descr="aica_evaluation_workspace_mockup_1784167999282.png"/>
           <p:cNvPicPr>
             <a:picLocks noChangeAspect="1"/>
           </p:cNvPicPr>
@@ -6288,8 +6305,8 @@
         </p:blipFill>
         <p:spPr>
           <a:xfrm>
-            <a:off x="6814049" y="1965960"/>
-            <a:ext cx="4385580" cy="3840480"/>
+            <a:off x="7086600" y="1965960"/>
+            <a:ext cx="3840480" cy="3840480"/>
           </a:xfrm>
           <a:prstGeom prst="rect">
             <a:avLst/>
@@ -6353,6 +6370,486 @@
               </a:defRPr>
             </a:pPr>
             <a:r>
+              <a:t>심사위원</a:t>
+            </a:r>
+          </a:p>
+        </p:txBody>
+      </p:sp>
+      <p:sp>
+        <p:nvSpPr>
+          <p:cNvPr id="3" name="TextBox 2"/>
+          <p:cNvSpPr txBox="1"/>
+          <p:nvPr/>
+        </p:nvSpPr>
+        <p:spPr>
+          <a:xfrm>
+            <a:off x="548640" y="640080"/>
+            <a:ext cx="10058400" cy="731520"/>
+          </a:xfrm>
+          <a:prstGeom prst="rect">
+            <a:avLst/>
+          </a:prstGeom>
+          <a:noFill/>
+        </p:spPr>
+        <p:txBody>
+          <a:bodyPr wrap="none">
+            <a:spAutoFit/>
+          </a:bodyPr>
+          <a:lstStyle/>
+          <a:p>
+            <a:pPr>
+              <a:defRPr sz="2600" b="1">
+                <a:solidFill>
+                  <a:srgbClr val="FFFFFF"/>
+                </a:solidFill>
+                <a:latin typeface="Noto Sans KR"/>
+              </a:defRPr>
+            </a:pPr>
+            <a:r>
+              <a:t>제출 전 마지막 확인이 평가 품질을 좌우합니다</a:t>
+            </a:r>
+          </a:p>
+        </p:txBody>
+      </p:sp>
+      <p:sp>
+        <p:nvSpPr>
+          <p:cNvPr id="4" name="Rectangle 3"/>
+          <p:cNvSpPr/>
+          <p:nvPr/>
+        </p:nvSpPr>
+        <p:spPr>
+          <a:xfrm>
+            <a:off x="548640" y="1371600"/>
+            <a:ext cx="11094415" cy="9144"/>
+          </a:xfrm>
+          <a:prstGeom prst="rect">
+            <a:avLst/>
+          </a:prstGeom>
+          <a:solidFill>
+            <a:srgbClr val="334155"/>
+          </a:solidFill>
+          <a:ln>
+            <a:noFill/>
+          </a:ln>
+        </p:spPr>
+        <p:style>
+          <a:lnRef idx="1">
+            <a:schemeClr val="accent1"/>
+          </a:lnRef>
+          <a:fillRef idx="3">
+            <a:schemeClr val="accent1"/>
+          </a:fillRef>
+          <a:effectRef idx="2">
+            <a:schemeClr val="accent1"/>
+          </a:effectRef>
+          <a:fontRef idx="minor">
+            <a:schemeClr val="lt1"/>
+          </a:fontRef>
+        </p:style>
+        <p:txBody>
+          <a:bodyPr rtlCol="0" anchor="ctr"/>
+          <a:lstStyle/>
+          <a:p>
+            <a:pPr algn="ctr"/>
+          </a:p>
+        </p:txBody>
+      </p:sp>
+      <p:sp>
+        <p:nvSpPr>
+          <p:cNvPr id="5" name="TextBox 4"/>
+          <p:cNvSpPr txBox="1"/>
+          <p:nvPr/>
+        </p:nvSpPr>
+        <p:spPr>
+          <a:xfrm>
+            <a:off x="548640" y="6309360"/>
+            <a:ext cx="9144000" cy="365760"/>
+          </a:xfrm>
+          <a:prstGeom prst="rect">
+            <a:avLst/>
+          </a:prstGeom>
+          <a:noFill/>
+        </p:spPr>
+        <p:txBody>
+          <a:bodyPr wrap="none">
+            <a:spAutoFit/>
+          </a:bodyPr>
+          <a:lstStyle/>
+          <a:p>
+            <a:pPr>
+              <a:defRPr sz="900">
+                <a:solidFill>
+                  <a:srgbClr val="94A3B8"/>
+                </a:solidFill>
+                <a:latin typeface="Noto Sans KR"/>
+              </a:defRPr>
+            </a:pPr>
+            <a:r>
+              <a:t>AICA 자격심사 시스템 사용자 매뉴얼 · Web App Dark Theme</a:t>
+            </a:r>
+          </a:p>
+        </p:txBody>
+      </p:sp>
+      <p:sp>
+        <p:nvSpPr>
+          <p:cNvPr id="6" name="TextBox 5"/>
+          <p:cNvSpPr txBox="1"/>
+          <p:nvPr/>
+        </p:nvSpPr>
+        <p:spPr>
+          <a:xfrm>
+            <a:off x="10820095" y="6309360"/>
+            <a:ext cx="822960" cy="365760"/>
+          </a:xfrm>
+          <a:prstGeom prst="rect">
+            <a:avLst/>
+          </a:prstGeom>
+          <a:noFill/>
+        </p:spPr>
+        <p:txBody>
+          <a:bodyPr wrap="none">
+            <a:spAutoFit/>
+          </a:bodyPr>
+          <a:lstStyle/>
+          <a:p>
+            <a:pPr algn="r">
+              <a:defRPr sz="900">
+                <a:solidFill>
+                  <a:srgbClr val="94A3B8"/>
+                </a:solidFill>
+                <a:latin typeface="Noto Sans KR"/>
+              </a:defRPr>
+            </a:pPr>
+            <a:r>
+              <a:t>15</a:t>
+            </a:r>
+          </a:p>
+        </p:txBody>
+      </p:sp>
+      <p:sp>
+        <p:nvSpPr>
+          <p:cNvPr id="7" name="Rounded Rectangle 6"/>
+          <p:cNvSpPr/>
+          <p:nvPr/>
+        </p:nvSpPr>
+        <p:spPr>
+          <a:xfrm>
+            <a:off x="548640" y="1828800"/>
+            <a:ext cx="5486400" cy="4114800"/>
+          </a:xfrm>
+          <a:prstGeom prst="roundRect">
+            <a:avLst/>
+          </a:prstGeom>
+          <a:solidFill>
+            <a:srgbClr val="1E293B"/>
+          </a:solidFill>
+          <a:ln w="12700">
+            <a:solidFill>
+              <a:srgbClr val="334155"/>
+            </a:solidFill>
+          </a:ln>
+        </p:spPr>
+        <p:style>
+          <a:lnRef idx="1">
+            <a:schemeClr val="accent1"/>
+          </a:lnRef>
+          <a:fillRef idx="3">
+            <a:schemeClr val="accent1"/>
+          </a:fillRef>
+          <a:effectRef idx="2">
+            <a:schemeClr val="accent1"/>
+          </a:effectRef>
+          <a:fontRef idx="minor">
+            <a:schemeClr val="lt1"/>
+          </a:fontRef>
+        </p:style>
+        <p:txBody>
+          <a:bodyPr rtlCol="0" anchor="ctr"/>
+          <a:lstStyle/>
+          <a:p>
+            <a:pPr algn="ctr"/>
+          </a:p>
+        </p:txBody>
+      </p:sp>
+      <p:sp>
+        <p:nvSpPr>
+          <p:cNvPr id="8" name="TextBox 7"/>
+          <p:cNvSpPr txBox="1"/>
+          <p:nvPr/>
+        </p:nvSpPr>
+        <p:spPr>
+          <a:xfrm>
+            <a:off x="731520" y="2011680"/>
+            <a:ext cx="5120640" cy="3749040"/>
+          </a:xfrm>
+          <a:prstGeom prst="rect">
+            <a:avLst/>
+          </a:prstGeom>
+          <a:noFill/>
+        </p:spPr>
+        <p:txBody>
+          <a:bodyPr wrap="square">
+            <a:spAutoFit/>
+          </a:bodyPr>
+          <a:lstStyle/>
+          <a:p>
+            <a:pPr>
+              <a:spcAft>
+                <a:spcPts val="1200"/>
+              </a:spcAft>
+              <a:defRPr sz="1500" b="1">
+                <a:solidFill>
+                  <a:srgbClr val="FFFFFF"/>
+                </a:solidFill>
+                <a:latin typeface="Noto Sans KR"/>
+              </a:defRPr>
+            </a:pPr>
+            <a:r>
+              <a:t>평가 최종 검토 및 제출 확정</a:t>
+            </a:r>
+          </a:p>
+          <a:p>
+            <a:pPr>
+              <a:spcAft>
+                <a:spcPts val="600"/>
+              </a:spcAft>
+              <a:defRPr sz="1100">
+                <a:solidFill>
+                  <a:srgbClr val="94A3B8"/>
+                </a:solidFill>
+                <a:latin typeface="Noto Sans KR"/>
+              </a:defRPr>
+            </a:pPr>
+            <a:r>
+              <a:t>평가 완료 및 전송 단계:</a:t>
+            </a:r>
+          </a:p>
+          <a:p>
+            <a:pPr>
+              <a:spcAft>
+                <a:spcPts val="600"/>
+              </a:spcAft>
+              <a:defRPr sz="1100">
+                <a:solidFill>
+                  <a:srgbClr val="94A3B8"/>
+                </a:solidFill>
+                <a:latin typeface="Noto Sans KR"/>
+              </a:defRPr>
+            </a:pPr>
+            <a:r>
+              <a:t>• 1. 필수값 체크: 보안 체크박스 준수, 루브릭 점수 선택, 세부 의견 누락 여부 최종 갱신</a:t>
+            </a:r>
+          </a:p>
+          <a:p>
+            <a:pPr>
+              <a:spcAft>
+                <a:spcPts val="600"/>
+              </a:spcAft>
+              <a:defRPr sz="1100">
+                <a:solidFill>
+                  <a:srgbClr val="94A3B8"/>
+                </a:solidFill>
+                <a:latin typeface="Noto Sans KR"/>
+              </a:defRPr>
+            </a:pPr>
+            <a:r>
+              <a:t>• 2. 타 위원 상태 검토: 타 위원의 점수 노출 없이 평가 진행률만 확인(독립적 판단 견지)</a:t>
+            </a:r>
+          </a:p>
+          <a:p>
+            <a:pPr>
+              <a:spcAft>
+                <a:spcPts val="600"/>
+              </a:spcAft>
+              <a:defRPr sz="1100">
+                <a:solidFill>
+                  <a:srgbClr val="94A3B8"/>
+                </a:solidFill>
+                <a:latin typeface="Noto Sans KR"/>
+              </a:defRPr>
+            </a:pPr>
+            <a:r>
+              <a:t>• 3. 평가 제출: [평가 완료 및 제출] 버튼을 선택해 데이터베이스 기록 완료</a:t>
+            </a:r>
+          </a:p>
+          <a:p>
+            <a:pPr>
+              <a:spcAft>
+                <a:spcPts val="600"/>
+              </a:spcAft>
+              <a:defRPr sz="1100">
+                <a:solidFill>
+                  <a:srgbClr val="94A3B8"/>
+                </a:solidFill>
+                <a:latin typeface="Noto Sans KR"/>
+              </a:defRPr>
+            </a:pPr>
+            <a:r>
+              <a:t>• 4. 상태 갱신 검증: 본인 대기 큐로 복귀 후 해당 과제 상태가 '완료'인지 확인</a:t>
+            </a:r>
+          </a:p>
+          <a:p>
+            <a:br/>
+            <a:pPr>
+              <a:spcAft>
+                <a:spcPts val="600"/>
+              </a:spcAft>
+              <a:defRPr sz="1100">
+                <a:solidFill>
+                  <a:srgbClr val="94A3B8"/>
+                </a:solidFill>
+                <a:latin typeface="Noto Sans KR"/>
+              </a:defRPr>
+            </a:pPr>
+            <a:r>
+              <a:t>💡 최종 판정 계산: 3인의 패널 심사위원이 최종 제출을 모두 완료하는 즉시 파이어스토어에서 평균 점수와 판정을 계산합니다.</a:t>
+            </a:r>
+          </a:p>
+          <a:p>
+            <a:br/>
+            <a:pPr>
+              <a:spcAft>
+                <a:spcPts val="600"/>
+              </a:spcAft>
+              <a:defRPr sz="1100">
+                <a:solidFill>
+                  <a:srgbClr val="94A3B8"/>
+                </a:solidFill>
+                <a:latin typeface="Noto Sans KR"/>
+              </a:defRPr>
+            </a:pPr>
+            <a:r>
+              <a:t>오른쪽 화면: 실제 채점 입력창 하단의 저장 및 최종 제출 영역</a:t>
+            </a:r>
+          </a:p>
+        </p:txBody>
+      </p:sp>
+      <p:sp>
+        <p:nvSpPr>
+          <p:cNvPr id="9" name="Rounded Rectangle 8"/>
+          <p:cNvSpPr/>
+          <p:nvPr/>
+        </p:nvSpPr>
+        <p:spPr>
+          <a:xfrm>
+            <a:off x="6400800" y="1828800"/>
+            <a:ext cx="5212080" cy="4114800"/>
+          </a:xfrm>
+          <a:prstGeom prst="roundRect">
+            <a:avLst/>
+          </a:prstGeom>
+          <a:solidFill>
+            <a:srgbClr val="1E293B"/>
+          </a:solidFill>
+          <a:ln w="19050">
+            <a:solidFill>
+              <a:srgbClr val="6366F1"/>
+            </a:solidFill>
+          </a:ln>
+        </p:spPr>
+        <p:style>
+          <a:lnRef idx="1">
+            <a:schemeClr val="accent1"/>
+          </a:lnRef>
+          <a:fillRef idx="3">
+            <a:schemeClr val="accent1"/>
+          </a:fillRef>
+          <a:effectRef idx="2">
+            <a:schemeClr val="accent1"/>
+          </a:effectRef>
+          <a:fontRef idx="minor">
+            <a:schemeClr val="lt1"/>
+          </a:fontRef>
+        </p:style>
+        <p:txBody>
+          <a:bodyPr rtlCol="0" anchor="ctr"/>
+          <a:lstStyle/>
+          <a:p>
+            <a:pPr algn="ctr"/>
+          </a:p>
+        </p:txBody>
+      </p:sp>
+      <p:pic>
+        <p:nvPicPr>
+          <p:cNvPr id="10" name="Picture 9" descr="media__1784176902473.png"/>
+          <p:cNvPicPr>
+            <a:picLocks noChangeAspect="1"/>
+          </p:cNvPicPr>
+          <p:nvPr/>
+        </p:nvPicPr>
+        <p:blipFill>
+          <a:blip r:embed="rId2"/>
+          <a:stretch>
+            <a:fillRect/>
+          </a:stretch>
+        </p:blipFill>
+        <p:spPr>
+          <a:xfrm>
+            <a:off x="6814049" y="1965960"/>
+            <a:ext cx="4385580" cy="3840480"/>
+          </a:xfrm>
+          <a:prstGeom prst="rect">
+            <a:avLst/>
+          </a:prstGeom>
+        </p:spPr>
+      </p:pic>
+    </p:spTree>
+  </p:cSld>
+  <p:clrMapOvr>
+    <a:masterClrMapping/>
+  </p:clrMapOvr>
+</p:sld>
+</file>
+
+<file path=ppt/slides/slide17.xml><?xml version="1.0" encoding="utf-8"?>
+<p:sld xmlns:a="http://schemas.openxmlformats.org/drawingml/2006/main" xmlns:p="http://schemas.openxmlformats.org/presentationml/2006/main" xmlns:r="http://schemas.openxmlformats.org/officeDocument/2006/relationships">
+  <p:cSld>
+    <p:bg>
+      <p:bgPr>
+        <a:solidFill>
+          <a:srgbClr val="0F172A"/>
+        </a:solidFill>
+        <a:effectLst/>
+      </p:bgPr>
+    </p:bg>
+    <p:spTree>
+      <p:nvGrpSpPr>
+        <p:cNvPr id="1" name=""/>
+        <p:cNvGrpSpPr/>
+        <p:nvPr/>
+      </p:nvGrpSpPr>
+      <p:grpSpPr/>
+      <p:sp>
+        <p:nvSpPr>
+          <p:cNvPr id="2" name="TextBox 1"/>
+          <p:cNvSpPr txBox="1"/>
+          <p:nvPr/>
+        </p:nvSpPr>
+        <p:spPr>
+          <a:xfrm>
+            <a:off x="548640" y="365760"/>
+            <a:ext cx="7315200" cy="365760"/>
+          </a:xfrm>
+          <a:prstGeom prst="rect">
+            <a:avLst/>
+          </a:prstGeom>
+          <a:noFill/>
+        </p:spPr>
+        <p:txBody>
+          <a:bodyPr wrap="none">
+            <a:spAutoFit/>
+          </a:bodyPr>
+          <a:lstStyle/>
+          <a:p>
+            <a:pPr>
+              <a:defRPr sz="1100" b="1">
+                <a:solidFill>
+                  <a:srgbClr val="38BDF8"/>
+                </a:solidFill>
+                <a:latin typeface="Noto Sans KR"/>
+              </a:defRPr>
+            </a:pPr>
+            <a:r>
               <a:t>공통</a:t>
             </a:r>
           </a:p>
@@ -8539,55 +9036,55 @@
               </a:defRPr>
             </a:pPr>
             <a:r>
-              <a:t>1. 시뮬레이션 데이터 불러오기: 가상의 테스트 데이터셋(후보자 9명 및 3인 패널 평가 결과) 복원</a:t>
-            </a:r>
-          </a:p>
-          <a:p>
-            <a:pPr>
-              <a:spcAft>
-                <a:spcPts val="600"/>
-              </a:spcAft>
-              <a:defRPr sz="1100">
-                <a:solidFill>
-                  <a:srgbClr val="94A3B8"/>
-                </a:solidFill>
-                <a:latin typeface="Noto Sans KR"/>
-              </a:defRPr>
-            </a:pPr>
-            <a:r>
-              <a:t>2. 데이터 초기화: 실무 운영 착수를 위해 전체 평가 과제 및 결과를 깨끗하게 초기화</a:t>
-            </a:r>
-          </a:p>
-          <a:p>
-            <a:pPr>
-              <a:spcAft>
-                <a:spcPts val="600"/>
-              </a:spcAft>
-              <a:defRPr sz="1100">
-                <a:solidFill>
-                  <a:srgbClr val="94A3B8"/>
-                </a:solidFill>
-                <a:latin typeface="Noto Sans KR"/>
-              </a:defRPr>
-            </a:pPr>
-            <a:r>
-              <a:t>3. 요약 지표: 전체, 완료, 진행 중, 대기 인원을 실시간 확인 (클릭 시 명단 모달 팝업)</a:t>
-            </a:r>
-          </a:p>
-          <a:p>
-            <a:pPr>
-              <a:spcAft>
-                <a:spcPts val="600"/>
-              </a:spcAft>
-              <a:defRPr sz="1100">
-                <a:solidFill>
-                  <a:srgbClr val="94A3B8"/>
-                </a:solidFill>
-                <a:latin typeface="Noto Sans KR"/>
-              </a:defRPr>
-            </a:pPr>
-            <a:r>
-              <a:t>4. 관계사 평균: 완료된 심사를 기준으로 계열사별 평균 점수를 모니터링</a:t>
+              <a:t>1. 월별 자격심사 일정: AICA L3/L4 심사일정을 캘린더로 한눈에 모니터링</a:t>
+            </a:r>
+          </a:p>
+          <a:p>
+            <a:pPr>
+              <a:spcAft>
+                <a:spcPts val="600"/>
+              </a:spcAft>
+              <a:defRPr sz="1100">
+                <a:solidFill>
+                  <a:srgbClr val="94A3B8"/>
+                </a:solidFill>
+                <a:latin typeface="Noto Sans KR"/>
+              </a:defRPr>
+            </a:pPr>
+            <a:r>
+              <a:t>2. 시뮬레이션 데이터 불러오기: 가상의 테스트 데이터셋(후보자 9명 및 3인 평가 결과) 복원</a:t>
+            </a:r>
+          </a:p>
+          <a:p>
+            <a:pPr>
+              <a:spcAft>
+                <a:spcPts val="600"/>
+              </a:spcAft>
+              <a:defRPr sz="1100">
+                <a:solidFill>
+                  <a:srgbClr val="94A3B8"/>
+                </a:solidFill>
+                <a:latin typeface="Noto Sans KR"/>
+              </a:defRPr>
+            </a:pPr>
+            <a:r>
+              <a:t>3. 데이터 초기화: 실무 운영 착수를 위해 전체 평가 과제 및 결과를 깨끗하게 초기화</a:t>
+            </a:r>
+          </a:p>
+          <a:p>
+            <a:pPr>
+              <a:spcAft>
+                <a:spcPts val="600"/>
+              </a:spcAft>
+              <a:defRPr sz="1100">
+                <a:solidFill>
+                  <a:srgbClr val="94A3B8"/>
+                </a:solidFill>
+                <a:latin typeface="Noto Sans KR"/>
+              </a:defRPr>
+            </a:pPr>
+            <a:r>
+              <a:t>4. 요약 지표: 전체, 완료, 진행 중, 대기 인원을 실시간 확인 (클릭 시 명단 모달 팝업)</a:t>
             </a:r>
           </a:p>
           <a:p>
@@ -8620,7 +9117,7 @@
               </a:defRPr>
             </a:pPr>
             <a:r>
-              <a:t>💡 대시보드 우측 상단 배지를 통해 테스트 시연용 가상 데이터 복원 및 실무용 초기화를 손쉽게 제어할 수 있습니다.</a:t>
+              <a:t>💡 대시보드 우측 상단 배지를 통해 시연용 가상 데이터 복원 및 실무용 초기화를 손쉽게 제어할 수 있습니다.</a:t>
             </a:r>
           </a:p>
           <a:p>
@@ -8768,7 +9265,7 @@
               </a:defRPr>
             </a:pPr>
             <a:r>
-              <a:t>운영간사</a:t>
+              <a:t>공통</a:t>
             </a:r>
           </a:p>
         </p:txBody>
@@ -8804,7 +9301,7 @@
               </a:defRPr>
             </a:pPr>
             <a:r>
-              <a:t>신규 과제는 필수 정보와 증빙을 한 번에 등록합니다</a:t>
+              <a:t>월별 자격심사 일정과 산출물 날짜가 명확히 연동됩니다</a:t>
             </a:r>
           </a:p>
         </p:txBody>
@@ -8919,7 +9416,7 @@
               </a:defRPr>
             </a:pPr>
             <a:r>
-              <a:t>06</a:t>
+              <a:t>05-B</a:t>
             </a:r>
           </a:p>
         </p:txBody>
@@ -9003,39 +9500,55 @@
               </a:defRPr>
             </a:pPr>
             <a:r>
-              <a:t>후보자 정보 및 증빙 링크 등록 폼</a:t>
-            </a:r>
-          </a:p>
-          <a:p>
-            <a:pPr>
-              <a:spcAft>
-                <a:spcPts val="600"/>
-              </a:spcAft>
-              <a:defRPr sz="1100">
-                <a:solidFill>
-                  <a:srgbClr val="94A3B8"/>
-                </a:solidFill>
-                <a:latin typeface="Noto Sans KR"/>
-              </a:defRPr>
-            </a:pPr>
-            <a:r>
-              <a:t>01 지원자 정보:</a:t>
-            </a:r>
-          </a:p>
-          <a:p>
-            <a:pPr>
-              <a:spcAft>
-                <a:spcPts val="600"/>
-              </a:spcAft>
-              <a:defRPr sz="1100">
-                <a:solidFill>
-                  <a:srgbClr val="94A3B8"/>
-                </a:solidFill>
-                <a:latin typeface="Noto Sans KR"/>
-              </a:defRPr>
-            </a:pPr>
-            <a:r>
-              <a:t>• 성명, 사내 이메일, 소속 관계사/부서, 자격 레벨(L3/L4), 과제 유형</a:t>
+              <a:t>월별 캘린더 연동 및 평가 산출물 일자 표기</a:t>
+            </a:r>
+          </a:p>
+          <a:p>
+            <a:pPr>
+              <a:spcAft>
+                <a:spcPts val="600"/>
+              </a:spcAft>
+              <a:defRPr sz="1100">
+                <a:solidFill>
+                  <a:srgbClr val="94A3B8"/>
+                </a:solidFill>
+                <a:latin typeface="Noto Sans KR"/>
+              </a:defRPr>
+            </a:pPr>
+            <a:r>
+              <a:t>1. 로그인 초기화면 월별 캘린더:</a:t>
+            </a:r>
+          </a:p>
+          <a:p>
+            <a:pPr>
+              <a:spcAft>
+                <a:spcPts val="600"/>
+              </a:spcAft>
+              <a:defRPr sz="1100">
+                <a:solidFill>
+                  <a:srgbClr val="94A3B8"/>
+                </a:solidFill>
+                <a:latin typeface="Noto Sans KR"/>
+              </a:defRPr>
+            </a:pPr>
+            <a:r>
+              <a:t>• 운영간사 및 심사위원 로그인 시 메인 화면에 캘린더가 렌더링됩니다.</a:t>
+            </a:r>
+          </a:p>
+          <a:p>
+            <a:pPr>
+              <a:spcAft>
+                <a:spcPts val="600"/>
+              </a:spcAft>
+              <a:defRPr sz="1100">
+                <a:solidFill>
+                  <a:srgbClr val="94A3B8"/>
+                </a:solidFill>
+                <a:latin typeface="Noto Sans KR"/>
+              </a:defRPr>
+            </a:pPr>
+            <a:r>
+              <a:t>• 심사일자에 [AICA L3 심사], [AICA L4 심사] 명칭으로 일정이 자동 기입됩니다.</a:t>
             </a:r>
           </a:p>
           <a:p>
@@ -9052,23 +9565,23 @@
               </a:defRPr>
             </a:pPr>
             <a:r>
-              <a:t>02 과제 내용 및 6S 요약:</a:t>
-            </a:r>
-          </a:p>
-          <a:p>
-            <a:pPr>
-              <a:spcAft>
-                <a:spcPts val="600"/>
-              </a:spcAft>
-              <a:defRPr sz="1100">
-                <a:solidFill>
-                  <a:srgbClr val="94A3B8"/>
-                </a:solidFill>
-                <a:latin typeface="Noto Sans KR"/>
-              </a:defRPr>
-            </a:pPr>
-            <a:r>
-              <a:t>• 평가 대상 과제명, Pain Point, AI 해결 방안, 핵심 기대효과 기술</a:t>
+              <a:t>2. 일정 클릭 시 화면 자동 이동:</a:t>
+            </a:r>
+          </a:p>
+          <a:p>
+            <a:pPr>
+              <a:spcAft>
+                <a:spcPts val="600"/>
+              </a:spcAft>
+              <a:defRPr sz="1100">
+                <a:solidFill>
+                  <a:srgbClr val="94A3B8"/>
+                </a:solidFill>
+                <a:latin typeface="Noto Sans KR"/>
+              </a:defRPr>
+            </a:pPr>
+            <a:r>
+              <a:t>• 캘린더 내 심사 일정을 클릭하면 운영간사는 대시보드/종합판정서로, 심사위원은 해당 배정 과제 평가 화면으로 즉시 이동합니다.</a:t>
             </a:r>
           </a:p>
           <a:p>
@@ -9085,23 +9598,39 @@
               </a:defRPr>
             </a:pPr>
             <a:r>
-              <a:t>03 증빙 파일 링크 등록:</a:t>
-            </a:r>
-          </a:p>
-          <a:p>
-            <a:pPr>
-              <a:spcAft>
-                <a:spcPts val="600"/>
-              </a:spcAft>
-              <a:defRPr sz="1100">
-                <a:solidFill>
-                  <a:srgbClr val="94A3B8"/>
-                </a:solidFill>
-                <a:latin typeface="Noto Sans KR"/>
-              </a:defRPr>
-            </a:pPr>
-            <a:r>
-              <a:t>• 디렉토리 구조 요약, 결과 보고서 PDF 주소, Git 소스코드 저장소, 시연 동영상 URL</a:t>
+              <a:t>3. 평가 산출물 명확한 날짜 표기:</a:t>
+            </a:r>
+          </a:p>
+          <a:p>
+            <a:pPr>
+              <a:spcAft>
+                <a:spcPts val="600"/>
+              </a:spcAft>
+              <a:defRPr sz="1100">
+                <a:solidFill>
+                  <a:srgbClr val="94A3B8"/>
+                </a:solidFill>
+                <a:latin typeface="Noto Sans KR"/>
+              </a:defRPr>
+            </a:pPr>
+            <a:r>
+              <a:t>• 종합판정서: 심사 시행 일자, 과제 제출 일시, 최종 승인 일시, 위원별 채점 제출 일시, 판정서 발행 일자 명시</a:t>
+            </a:r>
+          </a:p>
+          <a:p>
+            <a:pPr>
+              <a:spcAft>
+                <a:spcPts val="600"/>
+              </a:spcAft>
+              <a:defRPr sz="1100">
+                <a:solidFill>
+                  <a:srgbClr val="94A3B8"/>
+                </a:solidFill>
+                <a:latin typeface="Noto Sans KR"/>
+              </a:defRPr>
+            </a:pPr>
+            <a:r>
+              <a:t>• 평가 워크스페이스: 과제 제출일 및 심사 시행 예정일 실시간 상단 노출</a:t>
             </a:r>
           </a:p>
           <a:p>
@@ -9118,7 +9647,7 @@
               </a:defRPr>
             </a:pPr>
             <a:r>
-              <a:t>오른쪽 화면: 수동 과제 등록 및 패널 배정 기능이 활성화되는 대시보드 화면</a:t>
+              <a:t>오른쪽 화면: 실제 리액트 월별 캘린더 및 종합판정서 렌더링 화면</a:t>
             </a:r>
           </a:p>
         </p:txBody>
@@ -9285,7 +9814,7 @@
               </a:defRPr>
             </a:pPr>
             <a:r>
-              <a:t>패널은 전문분야별 1인씩, 이해상충 없이 배정합니다</a:t>
+              <a:t>신규 과제는 필수 정보와 증빙을 한 번에 등록합니다</a:t>
             </a:r>
           </a:p>
         </p:txBody>
@@ -9400,7 +9929,7 @@
               </a:defRPr>
             </a:pPr>
             <a:r>
-              <a:t>07</a:t>
+              <a:t>06</a:t>
             </a:r>
           </a:p>
         </p:txBody>
@@ -9484,55 +10013,39 @@
               </a:defRPr>
             </a:pPr>
             <a:r>
-              <a:t>심사 위원회 패널 구성 및 최적 추천</a:t>
-            </a:r>
-          </a:p>
-          <a:p>
-            <a:pPr>
-              <a:spcAft>
-                <a:spcPts val="600"/>
-              </a:spcAft>
-              <a:defRPr sz="1100">
-                <a:solidFill>
-                  <a:srgbClr val="94A3B8"/>
-                </a:solidFill>
-                <a:latin typeface="Noto Sans KR"/>
-              </a:defRPr>
-            </a:pPr>
-            <a:r>
-              <a:t>1. 현업·사업성 위원 (가치성 검증): 업무 프로세스 개선율 및 사업 효과성 채점</a:t>
-            </a:r>
-          </a:p>
-          <a:p>
-            <a:pPr>
-              <a:spcAft>
-                <a:spcPts val="600"/>
-              </a:spcAft>
-              <a:defRPr sz="1100">
-                <a:solidFill>
-                  <a:srgbClr val="94A3B8"/>
-                </a:solidFill>
-                <a:latin typeface="Noto Sans KR"/>
-              </a:defRPr>
-            </a:pPr>
-            <a:r>
-              <a:t>2. AI·기술 위원 (구현성 검증): 기술적 난이도 및 구현 완성도 채점</a:t>
-            </a:r>
-          </a:p>
-          <a:p>
-            <a:pPr>
-              <a:spcAft>
-                <a:spcPts val="600"/>
-              </a:spcAft>
-              <a:defRPr sz="1100">
-                <a:solidFill>
-                  <a:srgbClr val="94A3B8"/>
-                </a:solidFill>
-                <a:latin typeface="Noto Sans KR"/>
-              </a:defRPr>
-            </a:pPr>
-            <a:r>
-              <a:t>3. 보안·거버넌스 위원 (신뢰성 검증): 데이터 활용 보안 및 내부 가이드 채점</a:t>
+              <a:t>후보자 정보 및 증빙 링크 등록 폼</a:t>
+            </a:r>
+          </a:p>
+          <a:p>
+            <a:pPr>
+              <a:spcAft>
+                <a:spcPts val="600"/>
+              </a:spcAft>
+              <a:defRPr sz="1100">
+                <a:solidFill>
+                  <a:srgbClr val="94A3B8"/>
+                </a:solidFill>
+                <a:latin typeface="Noto Sans KR"/>
+              </a:defRPr>
+            </a:pPr>
+            <a:r>
+              <a:t>01 지원자 정보:</a:t>
+            </a:r>
+          </a:p>
+          <a:p>
+            <a:pPr>
+              <a:spcAft>
+                <a:spcPts val="600"/>
+              </a:spcAft>
+              <a:defRPr sz="1100">
+                <a:solidFill>
+                  <a:srgbClr val="94A3B8"/>
+                </a:solidFill>
+                <a:latin typeface="Noto Sans KR"/>
+              </a:defRPr>
+            </a:pPr>
+            <a:r>
+              <a:t>• 성명, 사내 이메일, 소속 관계사/부서, 자격 레벨(L3/L4), 과제 유형</a:t>
             </a:r>
           </a:p>
           <a:p>
@@ -9549,23 +10062,23 @@
               </a:defRPr>
             </a:pPr>
             <a:r>
-              <a:t>⚡ 최적 패널 자동 추천 로직:</a:t>
-            </a:r>
-          </a:p>
-          <a:p>
-            <a:pPr>
-              <a:spcAft>
-                <a:spcPts val="600"/>
-              </a:spcAft>
-              <a:defRPr sz="1100">
-                <a:solidFill>
-                  <a:srgbClr val="94A3B8"/>
-                </a:solidFill>
-                <a:latin typeface="Noto Sans KR"/>
-              </a:defRPr>
-            </a:pPr>
-            <a:r>
-              <a:t>• 피평가자와 동일한 사명 소속 위원을 자동 배제하여 후보군을 우선 순위 정렬합니다.</a:t>
+              <a:t>02 과제 내용 및 6S 요약:</a:t>
+            </a:r>
+          </a:p>
+          <a:p>
+            <a:pPr>
+              <a:spcAft>
+                <a:spcPts val="600"/>
+              </a:spcAft>
+              <a:defRPr sz="1100">
+                <a:solidFill>
+                  <a:srgbClr val="94A3B8"/>
+                </a:solidFill>
+                <a:latin typeface="Noto Sans KR"/>
+              </a:defRPr>
+            </a:pPr>
+            <a:r>
+              <a:t>• 평가 대상 과제명, Pain Point, AI 해결 방안, 핵심 기대효과 기술</a:t>
             </a:r>
           </a:p>
           <a:p>
@@ -9582,7 +10095,23 @@
               </a:defRPr>
             </a:pPr>
             <a:r>
-              <a:t>⚠️ 간사가 위원을 직접 수동 선택하는 경우, 소속이 일치하는 위원 옆에는 빨간색 [이해상충 주의] 레이블이 노출됩니다.</a:t>
+              <a:t>03 증빙 파일 링크 등록:</a:t>
+            </a:r>
+          </a:p>
+          <a:p>
+            <a:pPr>
+              <a:spcAft>
+                <a:spcPts val="600"/>
+              </a:spcAft>
+              <a:defRPr sz="1100">
+                <a:solidFill>
+                  <a:srgbClr val="94A3B8"/>
+                </a:solidFill>
+                <a:latin typeface="Noto Sans KR"/>
+              </a:defRPr>
+            </a:pPr>
+            <a:r>
+              <a:t>• 디렉토리 구조 요약, 결과 보고서 PDF 주소, Git 소스코드 저장소, 시연 동영상 URL</a:t>
             </a:r>
           </a:p>
           <a:p>
@@ -9599,7 +10128,7 @@
               </a:defRPr>
             </a:pPr>
             <a:r>
-              <a:t>오른쪽 화면: 대시보드 우측의 위원 배정 큐 영역</a:t>
+              <a:t>오른쪽 화면: 수동 과제 등록 및 패널 배정 기능이 활성화되는 대시보드 화면</a:t>
             </a:r>
           </a:p>
         </p:txBody>
@@ -9766,7 +10295,7 @@
               </a:defRPr>
             </a:pPr>
             <a:r>
-              <a:t>필터와 상태값으로 병목을 빠르게 찾습니다</a:t>
+              <a:t>패널은 전문분야별 1인씩, 이해상충 없이 배정합니다</a:t>
             </a:r>
           </a:p>
         </p:txBody>
@@ -9881,7 +10410,7 @@
               </a:defRPr>
             </a:pPr>
             <a:r>
-              <a:t>08</a:t>
+              <a:t>07</a:t>
             </a:r>
           </a:p>
         </p:txBody>
@@ -9965,103 +10494,55 @@
               </a:defRPr>
             </a:pPr>
             <a:r>
-              <a:t>진행 상태 분기 및 필터 모니터링</a:t>
-            </a:r>
-          </a:p>
-          <a:p>
-            <a:pPr>
-              <a:spcAft>
-                <a:spcPts val="600"/>
-              </a:spcAft>
-              <a:defRPr sz="1100">
-                <a:solidFill>
-                  <a:srgbClr val="94A3B8"/>
-                </a:solidFill>
-                <a:latin typeface="Noto Sans KR"/>
-              </a:defRPr>
-            </a:pPr>
-            <a:r>
-              <a:t>통합 대기 큐 및 필터 시스템 활용법:</a:t>
-            </a:r>
-          </a:p>
-          <a:p>
-            <a:pPr>
-              <a:spcAft>
-                <a:spcPts val="600"/>
-              </a:spcAft>
-              <a:defRPr sz="1100">
-                <a:solidFill>
-                  <a:srgbClr val="94A3B8"/>
-                </a:solidFill>
-                <a:latin typeface="Noto Sans KR"/>
-              </a:defRPr>
-            </a:pPr>
-            <a:r>
-              <a:t>• 필터 종류: 관계사별, 인증 레벨별, 평가 진행 상태별 필터 제공</a:t>
-            </a:r>
-          </a:p>
-          <a:p>
-            <a:pPr>
-              <a:spcAft>
-                <a:spcPts val="600"/>
-              </a:spcAft>
-              <a:defRPr sz="1100">
-                <a:solidFill>
-                  <a:srgbClr val="94A3B8"/>
-                </a:solidFill>
-                <a:latin typeface="Noto Sans KR"/>
-              </a:defRPr>
-            </a:pPr>
-            <a:r>
-              <a:t>• 1. 평가대기: 패널 배정 완료 후 아직 위원이 채점을 시작하지 않음</a:t>
-            </a:r>
-          </a:p>
-          <a:p>
-            <a:pPr>
-              <a:spcAft>
-                <a:spcPts val="600"/>
-              </a:spcAft>
-              <a:defRPr sz="1100">
-                <a:solidFill>
-                  <a:srgbClr val="94A3B8"/>
-                </a:solidFill>
-                <a:latin typeface="Noto Sans KR"/>
-              </a:defRPr>
-            </a:pPr>
-            <a:r>
-              <a:t>• 2. 심사중: 1명 이상의 위원이 부분 채점을 기록하거나 제출함</a:t>
-            </a:r>
-          </a:p>
-          <a:p>
-            <a:pPr>
-              <a:spcAft>
-                <a:spcPts val="600"/>
-              </a:spcAft>
-              <a:defRPr sz="1100">
-                <a:solidFill>
-                  <a:srgbClr val="94A3B8"/>
-                </a:solidFill>
-                <a:latin typeface="Noto Sans KR"/>
-              </a:defRPr>
-            </a:pPr>
-            <a:r>
-              <a:t>• 3. 완료: 3인 패널이 모두 최종 평가를 제출하여 종합 평균이 집계됨</a:t>
-            </a:r>
-          </a:p>
-          <a:p>
-            <a:pPr>
-              <a:spcAft>
-                <a:spcPts val="600"/>
-              </a:spcAft>
-              <a:defRPr sz="1100">
-                <a:solidFill>
-                  <a:srgbClr val="94A3B8"/>
-                </a:solidFill>
-                <a:latin typeface="Noto Sans KR"/>
-              </a:defRPr>
-            </a:pPr>
-            <a:r>
-              <a:t>• 4. 보고서 보기: [결과 보기] 액션 버튼을 눌러 종합판정서 조회 및 인쇄</a:t>
+              <a:t>심사 위원회 패널 구성 및 최적 추천</a:t>
+            </a:r>
+          </a:p>
+          <a:p>
+            <a:pPr>
+              <a:spcAft>
+                <a:spcPts val="600"/>
+              </a:spcAft>
+              <a:defRPr sz="1100">
+                <a:solidFill>
+                  <a:srgbClr val="94A3B8"/>
+                </a:solidFill>
+                <a:latin typeface="Noto Sans KR"/>
+              </a:defRPr>
+            </a:pPr>
+            <a:r>
+              <a:t>1. 현업·사업성 위원 (가치성 검증): 업무 프로세스 개선율 및 사업 효과성 채점</a:t>
+            </a:r>
+          </a:p>
+          <a:p>
+            <a:pPr>
+              <a:spcAft>
+                <a:spcPts val="600"/>
+              </a:spcAft>
+              <a:defRPr sz="1100">
+                <a:solidFill>
+                  <a:srgbClr val="94A3B8"/>
+                </a:solidFill>
+                <a:latin typeface="Noto Sans KR"/>
+              </a:defRPr>
+            </a:pPr>
+            <a:r>
+              <a:t>2. AI·기술 위원 (구현성 검증): 기술적 난이도 및 구현 완성도 채점</a:t>
+            </a:r>
+          </a:p>
+          <a:p>
+            <a:pPr>
+              <a:spcAft>
+                <a:spcPts val="600"/>
+              </a:spcAft>
+              <a:defRPr sz="1100">
+                <a:solidFill>
+                  <a:srgbClr val="94A3B8"/>
+                </a:solidFill>
+                <a:latin typeface="Noto Sans KR"/>
+              </a:defRPr>
+            </a:pPr>
+            <a:r>
+              <a:t>3. 보안·거버넌스 위원 (신뢰성 검증): 데이터 활용 보안 및 내부 가이드 채점</a:t>
             </a:r>
           </a:p>
           <a:p>
@@ -10078,7 +10559,23 @@
               </a:defRPr>
             </a:pPr>
             <a:r>
-              <a:t>💡 팁: '타 위원 진척도' 항목에서 실시간 배지 도트를 확인해 미제출 위원을 즉시 판별할 수 있습니다.</a:t>
+              <a:t>⚡ 최적 패널 자동 추천 로직:</a:t>
+            </a:r>
+          </a:p>
+          <a:p>
+            <a:pPr>
+              <a:spcAft>
+                <a:spcPts val="600"/>
+              </a:spcAft>
+              <a:defRPr sz="1100">
+                <a:solidFill>
+                  <a:srgbClr val="94A3B8"/>
+                </a:solidFill>
+                <a:latin typeface="Noto Sans KR"/>
+              </a:defRPr>
+            </a:pPr>
+            <a:r>
+              <a:t>• 피평가자와 동일한 사명 소속 위원을 자동 배제하여 후보군을 우선 순위 정렬합니다.</a:t>
             </a:r>
           </a:p>
           <a:p>
@@ -10095,7 +10592,24 @@
               </a:defRPr>
             </a:pPr>
             <a:r>
-              <a:t>오른쪽 화면: 간사용 대기 큐 필터 및 위원 진척 표시 영역</a:t>
+              <a:t>⚠️ 간사가 위원을 직접 수동 선택하는 경우, 소속이 일치하는 위원 옆에는 빨간색 [이해상충 주의] 레이블이 노출됩니다.</a:t>
+            </a:r>
+          </a:p>
+          <a:p>
+            <a:br/>
+            <a:pPr>
+              <a:spcAft>
+                <a:spcPts val="600"/>
+              </a:spcAft>
+              <a:defRPr sz="1100">
+                <a:solidFill>
+                  <a:srgbClr val="94A3B8"/>
+                </a:solidFill>
+                <a:latin typeface="Noto Sans KR"/>
+              </a:defRPr>
+            </a:pPr>
+            <a:r>
+              <a:t>오른쪽 화면: 대시보드 우측의 위원 배정 큐 영역</a:t>
             </a:r>
           </a:p>
         </p:txBody>
@@ -10262,7 +10776,7 @@
               </a:defRPr>
             </a:pPr>
             <a:r>
-              <a:t>3인 제출 후 종합판정서가 완성됩니다</a:t>
+              <a:t>필터와 상태값으로 병목을 빠르게 찾습니다</a:t>
             </a:r>
           </a:p>
         </p:txBody>
@@ -10377,7 +10891,7 @@
               </a:defRPr>
             </a:pPr>
             <a:r>
-              <a:t>09</a:t>
+              <a:t>08</a:t>
             </a:r>
           </a:p>
         </p:txBody>
@@ -10461,87 +10975,103 @@
               </a:defRPr>
             </a:pPr>
             <a:r>
-              <a:t>종합판정 보고서 발급 및 명패 동기화</a:t>
-            </a:r>
-          </a:p>
-          <a:p>
-            <a:pPr>
-              <a:spcAft>
-                <a:spcPts val="600"/>
-              </a:spcAft>
-              <a:defRPr sz="1100">
-                <a:solidFill>
-                  <a:srgbClr val="94A3B8"/>
-                </a:solidFill>
-                <a:latin typeface="Noto Sans KR"/>
-              </a:defRPr>
-            </a:pPr>
-            <a:r>
-              <a:t>종합판정서 구성 항목 및 검증 가이드:</a:t>
-            </a:r>
-          </a:p>
-          <a:p>
-            <a:pPr>
-              <a:spcAft>
-                <a:spcPts val="600"/>
-              </a:spcAft>
-              <a:defRPr sz="1100">
-                <a:solidFill>
-                  <a:srgbClr val="94A3B8"/>
-                </a:solidFill>
-                <a:latin typeface="Noto Sans KR"/>
-              </a:defRPr>
-            </a:pPr>
-            <a:r>
-              <a:t>• 지원자 기본 정보 및 종합 평균 점수 시각화</a:t>
-            </a:r>
-          </a:p>
-          <a:p>
-            <a:pPr>
-              <a:spcAft>
-                <a:spcPts val="600"/>
-              </a:spcAft>
-              <a:defRPr sz="1100">
-                <a:solidFill>
-                  <a:srgbClr val="94A3B8"/>
-                </a:solidFill>
-                <a:latin typeface="Noto Sans KR"/>
-              </a:defRPr>
-            </a:pPr>
-            <a:r>
-              <a:t>• 3인 배정 위원의 세부 루브릭 채점 점수 및 종합 정성 평가 의견 노출</a:t>
-            </a:r>
-          </a:p>
-          <a:p>
-            <a:pPr>
-              <a:spcAft>
-                <a:spcPts val="600"/>
-              </a:spcAft>
-              <a:defRPr sz="1100">
-                <a:solidFill>
-                  <a:srgbClr val="94A3B8"/>
-                </a:solidFill>
-                <a:latin typeface="Noto Sans KR"/>
-              </a:defRPr>
-            </a:pPr>
-            <a:r>
-              <a:t>• 하단 서명란: 배정된 실제 심사위원 성명으로 명패 자동 변경 완료</a:t>
-            </a:r>
-          </a:p>
-          <a:p>
-            <a:pPr>
-              <a:spcAft>
-                <a:spcPts val="600"/>
-              </a:spcAft>
-              <a:defRPr sz="1100">
-                <a:solidFill>
-                  <a:srgbClr val="94A3B8"/>
-                </a:solidFill>
-                <a:latin typeface="Noto Sans KR"/>
-              </a:defRPr>
-            </a:pPr>
-            <a:r>
-              <a:t>• 출력 최적화: [결과 보고서 인쇄 (PDF)] 버튼을 클릭하여 A4 최적화 보고서 출력 및 사내 공유용 저장 가능</a:t>
+              <a:t>진행 상태 분기 및 필터 모니터링</a:t>
+            </a:r>
+          </a:p>
+          <a:p>
+            <a:pPr>
+              <a:spcAft>
+                <a:spcPts val="600"/>
+              </a:spcAft>
+              <a:defRPr sz="1100">
+                <a:solidFill>
+                  <a:srgbClr val="94A3B8"/>
+                </a:solidFill>
+                <a:latin typeface="Noto Sans KR"/>
+              </a:defRPr>
+            </a:pPr>
+            <a:r>
+              <a:t>통합 대기 큐 및 필터 시스템 활용법:</a:t>
+            </a:r>
+          </a:p>
+          <a:p>
+            <a:pPr>
+              <a:spcAft>
+                <a:spcPts val="600"/>
+              </a:spcAft>
+              <a:defRPr sz="1100">
+                <a:solidFill>
+                  <a:srgbClr val="94A3B8"/>
+                </a:solidFill>
+                <a:latin typeface="Noto Sans KR"/>
+              </a:defRPr>
+            </a:pPr>
+            <a:r>
+              <a:t>• 필터 종류: 관계사별, 인증 레벨별, 평가 진행 상태별 필터 제공</a:t>
+            </a:r>
+          </a:p>
+          <a:p>
+            <a:pPr>
+              <a:spcAft>
+                <a:spcPts val="600"/>
+              </a:spcAft>
+              <a:defRPr sz="1100">
+                <a:solidFill>
+                  <a:srgbClr val="94A3B8"/>
+                </a:solidFill>
+                <a:latin typeface="Noto Sans KR"/>
+              </a:defRPr>
+            </a:pPr>
+            <a:r>
+              <a:t>• 1. 평가대기: 패널 배정 완료 후 아직 위원이 채점을 시작하지 않음</a:t>
+            </a:r>
+          </a:p>
+          <a:p>
+            <a:pPr>
+              <a:spcAft>
+                <a:spcPts val="600"/>
+              </a:spcAft>
+              <a:defRPr sz="1100">
+                <a:solidFill>
+                  <a:srgbClr val="94A3B8"/>
+                </a:solidFill>
+                <a:latin typeface="Noto Sans KR"/>
+              </a:defRPr>
+            </a:pPr>
+            <a:r>
+              <a:t>• 2. 심사중: 1명 이상의 위원이 부분 채점을 기록하거나 제출함</a:t>
+            </a:r>
+          </a:p>
+          <a:p>
+            <a:pPr>
+              <a:spcAft>
+                <a:spcPts val="600"/>
+              </a:spcAft>
+              <a:defRPr sz="1100">
+                <a:solidFill>
+                  <a:srgbClr val="94A3B8"/>
+                </a:solidFill>
+                <a:latin typeface="Noto Sans KR"/>
+              </a:defRPr>
+            </a:pPr>
+            <a:r>
+              <a:t>• 3. 완료: 3인 패널이 모두 최종 평가를 제출하여 종합 평균이 집계됨</a:t>
+            </a:r>
+          </a:p>
+          <a:p>
+            <a:pPr>
+              <a:spcAft>
+                <a:spcPts val="600"/>
+              </a:spcAft>
+              <a:defRPr sz="1100">
+                <a:solidFill>
+                  <a:srgbClr val="94A3B8"/>
+                </a:solidFill>
+                <a:latin typeface="Noto Sans KR"/>
+              </a:defRPr>
+            </a:pPr>
+            <a:r>
+              <a:t>• 4. 보고서 보기: [결과 보기] 액션 버튼을 눌러 종합판정서 조회 및 인쇄</a:t>
             </a:r>
           </a:p>
           <a:p>
@@ -10558,23 +11088,7 @@
               </a:defRPr>
             </a:pPr>
             <a:r>
-              <a:t>⚠️ 결격 사유 발생 시:</a:t>
-            </a:r>
-          </a:p>
-          <a:p>
-            <a:pPr>
-              <a:spcAft>
-                <a:spcPts val="600"/>
-              </a:spcAft>
-              <a:defRPr sz="1100">
-                <a:solidFill>
-                  <a:srgbClr val="94A3B8"/>
-                </a:solidFill>
-                <a:latin typeface="Noto Sans KR"/>
-              </a:defRPr>
-            </a:pPr>
-            <a:r>
-              <a:t>• 표절, 중요 기밀 및 API Key 노출 등이 발견되어 결격 처리된 경우, 평균 점수가 70점 이상이어도 최종 판정은 '불합격' 처리됩니다.</a:t>
+              <a:t>💡 팁: '타 위원 진척도' 항목에서 실시간 배지 도트를 확인해 미제출 위원을 즉시 판별할 수 있습니다.</a:t>
             </a:r>
           </a:p>
           <a:p>
@@ -10591,7 +11105,7 @@
               </a:defRPr>
             </a:pPr>
             <a:r>
-              <a:t>오른쪽 화면: 서명이 실제 심사위원 성명으로 연동된 결과 보고서 하단부</a:t>
+              <a:t>오른쪽 화면: 간사용 대기 큐 필터 및 위원 진척 표시 영역</a:t>
             </a:r>
           </a:p>
         </p:txBody>
@@ -10643,7 +11157,7 @@
       </p:sp>
       <p:pic>
         <p:nvPicPr>
-          <p:cNvPr id="10" name="Picture 9" descr="media__1784596287593.png"/>
+          <p:cNvPr id="10" name="Picture 9" descr="media__1784188798650.png"/>
           <p:cNvPicPr>
             <a:picLocks noChangeAspect="1"/>
           </p:cNvPicPr>
@@ -10657,8 +11171,8 @@
         </p:blipFill>
         <p:spPr>
           <a:xfrm>
-            <a:off x="7059982" y="1965960"/>
-            <a:ext cx="3893714" cy="3840480"/>
+            <a:off x="7369320" y="1965960"/>
+            <a:ext cx="3275038" cy="3840480"/>
           </a:xfrm>
           <a:prstGeom prst="rect">
             <a:avLst/>

</xml_diff>

<commit_message>
feat: Implement 16:9 aspect ratio Demo Sandbox viewport with live demo interactive preview and update 20-page manual
</commit_message>
<xml_diff>
--- a/AICA_System_User_Manual.pptx
+++ b/AICA_System_User_Manual.pptx
@@ -5510,7 +5510,7 @@
               </a:defRPr>
             </a:pPr>
             <a:r>
-              <a:t>시연 동영상 및 외부 링크 검증:</a:t>
+              <a:t>16:9 데모 샌드박스 플레이어 &amp; 라이브 미리보기:</a:t>
             </a:r>
           </a:p>
           <a:p>
@@ -5526,7 +5526,7 @@
               </a:defRPr>
             </a:pPr>
             <a:r>
-              <a:t>• 사내 데모 샌드박스 동영상 모의 플레이어 구동</a:t>
+              <a:t>• 16:9 표준 비율 창: 뷰포트 규격에 최적화된 16대9 디스플레이 플레이어 탑재</a:t>
             </a:r>
           </a:p>
           <a:p>
@@ -5542,7 +5542,7 @@
               </a:defRPr>
             </a:pPr>
             <a:r>
-              <a:t>• 과제 증빙용 하이퍼링크 3종 검증:</a:t>
+              <a:t>• 라이브 데모 연동 미리보기: 심사 창 내부 뷰포트(iframe)에서 데모 웹 앱을 직접 가동 및 미리보기</a:t>
             </a:r>
           </a:p>
           <a:p>
@@ -5552,13 +5552,30 @@
               </a:spcAft>
               <a:defRPr sz="1200">
                 <a:solidFill>
+                  <a:srgbClr val="FFFFFF"/>
+                </a:solidFill>
+                <a:latin typeface="Malgun Gothic"/>
+              </a:defRPr>
+            </a:pPr>
+            <a:r>
+              <a:t>• MP4 동영상 재생 모드: 시연 MP4 동영상 플레이어 및 타임라인 슬라이더 연동</a:t>
+            </a:r>
+          </a:p>
+          <a:p>
+            <a:br/>
+            <a:pPr>
+              <a:spcAft>
+                <a:spcPts val="600"/>
+              </a:spcAft>
+              <a:defRPr sz="1200">
+                <a:solidFill>
                   <a:srgbClr val="E2E8F0"/>
                 </a:solidFill>
                 <a:latin typeface="Malgun Gothic"/>
               </a:defRPr>
             </a:pPr>
             <a:r>
-              <a:t>  - 결과 보고서 원본 (그룹웨어 PDF)</a:t>
+              <a:t>과제 증빙용 하이퍼링크 3종 검증:</a:t>
             </a:r>
           </a:p>
           <a:p>
@@ -5568,13 +5585,13 @@
               </a:spcAft>
               <a:defRPr sz="1200">
                 <a:solidFill>
-                  <a:srgbClr val="E2E8F0"/>
-                </a:solidFill>
-                <a:latin typeface="Malgun Gothic"/>
-              </a:defRPr>
-            </a:pPr>
-            <a:r>
-              <a:t>  - 코드 저장소 (GitLab Repository)</a:t>
+                  <a:srgbClr val="FFFFFF"/>
+                </a:solidFill>
+                <a:latin typeface="Malgun Gothic"/>
+              </a:defRPr>
+            </a:pPr>
+            <a:r>
+              <a:t>• 1. 결과 보고서 원본 (그룹웨어 PDF)</a:t>
             </a:r>
           </a:p>
           <a:p>
@@ -5584,13 +5601,29 @@
               </a:spcAft>
               <a:defRPr sz="1200">
                 <a:solidFill>
-                  <a:srgbClr val="E2E8F0"/>
-                </a:solidFill>
-                <a:latin typeface="Malgun Gothic"/>
-              </a:defRPr>
-            </a:pPr>
-            <a:r>
-              <a:t>  - 실제 구동 데모 (사내 Sandbox URL)</a:t>
+                  <a:srgbClr val="FFFFFF"/>
+                </a:solidFill>
+                <a:latin typeface="Malgun Gothic"/>
+              </a:defRPr>
+            </a:pPr>
+            <a:r>
+              <a:t>• 2. 코드 저장소 (GitLab Repository)</a:t>
+            </a:r>
+          </a:p>
+          <a:p>
+            <a:pPr>
+              <a:spcAft>
+                <a:spcPts val="600"/>
+              </a:spcAft>
+              <a:defRPr sz="1200">
+                <a:solidFill>
+                  <a:srgbClr val="FFFFFF"/>
+                </a:solidFill>
+                <a:latin typeface="Malgun Gothic"/>
+              </a:defRPr>
+            </a:pPr>
+            <a:r>
+              <a:t>• 3. 실제 구동 데모 (사내 Sandbox URL)</a:t>
             </a:r>
           </a:p>
         </p:txBody>

</xml_diff>